<commit_message>
docs(presentation): preserve comprehensive deck update
</commit_message>
<xml_diff>
--- a/BuahSafe_Super_Comprehensive_Presentation_Deep_Dive.pptx
+++ b/BuahSafe_Super_Comprehensive_Presentation_Deep_Dive.pptx
@@ -5,44 +5,44 @@
     <p:sldMasterId id="2147483648" r:id="rId1"/>
   </p:sldMasterIdLst>
   <p:sldIdLst>
-    <p:sldId id="256" r:id="rId7"/>
-    <p:sldId id="257" r:id="rId8"/>
-    <p:sldId id="258" r:id="rId9"/>
-    <p:sldId id="259" r:id="rId10"/>
-    <p:sldId id="260" r:id="rId11"/>
-    <p:sldId id="261" r:id="rId12"/>
-    <p:sldId id="262" r:id="rId13"/>
-    <p:sldId id="263" r:id="rId14"/>
-    <p:sldId id="264" r:id="rId15"/>
-    <p:sldId id="265" r:id="rId16"/>
-    <p:sldId id="266" r:id="rId17"/>
-    <p:sldId id="267" r:id="rId18"/>
-    <p:sldId id="268" r:id="rId19"/>
-    <p:sldId id="269" r:id="rId20"/>
-    <p:sldId id="270" r:id="rId21"/>
-    <p:sldId id="271" r:id="rId22"/>
-    <p:sldId id="272" r:id="rId23"/>
-    <p:sldId id="273" r:id="rId24"/>
-    <p:sldId id="274" r:id="rId25"/>
-    <p:sldId id="275" r:id="rId26"/>
-    <p:sldId id="276" r:id="rId27"/>
-    <p:sldId id="277" r:id="rId28"/>
-    <p:sldId id="278" r:id="rId29"/>
-    <p:sldId id="279" r:id="rId30"/>
-    <p:sldId id="280" r:id="rId31"/>
-    <p:sldId id="281" r:id="rId32"/>
-    <p:sldId id="282" r:id="rId33"/>
-    <p:sldId id="283" r:id="rId34"/>
-    <p:sldId id="284" r:id="rId35"/>
-    <p:sldId id="285" r:id="rId36"/>
-    <p:sldId id="286" r:id="rId37"/>
-    <p:sldId id="287" r:id="rId38"/>
-    <p:sldId id="288" r:id="rId39"/>
-    <p:sldId id="289" r:id="rId40"/>
-    <p:sldId id="290" r:id="rId41"/>
-    <p:sldId id="291" r:id="rId42"/>
+    <p:sldId id="256" r:id="rId2"/>
+    <p:sldId id="257" r:id="rId3"/>
+    <p:sldId id="258" r:id="rId4"/>
+    <p:sldId id="259" r:id="rId5"/>
+    <p:sldId id="260" r:id="rId6"/>
+    <p:sldId id="261" r:id="rId7"/>
+    <p:sldId id="262" r:id="rId8"/>
+    <p:sldId id="263" r:id="rId9"/>
+    <p:sldId id="264" r:id="rId10"/>
+    <p:sldId id="265" r:id="rId11"/>
+    <p:sldId id="266" r:id="rId12"/>
+    <p:sldId id="267" r:id="rId13"/>
+    <p:sldId id="268" r:id="rId14"/>
+    <p:sldId id="269" r:id="rId15"/>
+    <p:sldId id="270" r:id="rId16"/>
+    <p:sldId id="271" r:id="rId17"/>
+    <p:sldId id="272" r:id="rId18"/>
+    <p:sldId id="273" r:id="rId19"/>
+    <p:sldId id="274" r:id="rId20"/>
+    <p:sldId id="275" r:id="rId21"/>
+    <p:sldId id="276" r:id="rId22"/>
+    <p:sldId id="277" r:id="rId23"/>
+    <p:sldId id="278" r:id="rId24"/>
+    <p:sldId id="279" r:id="rId25"/>
+    <p:sldId id="280" r:id="rId26"/>
+    <p:sldId id="281" r:id="rId27"/>
+    <p:sldId id="282" r:id="rId28"/>
+    <p:sldId id="283" r:id="rId29"/>
+    <p:sldId id="284" r:id="rId30"/>
+    <p:sldId id="285" r:id="rId31"/>
+    <p:sldId id="286" r:id="rId32"/>
+    <p:sldId id="287" r:id="rId33"/>
+    <p:sldId id="288" r:id="rId34"/>
+    <p:sldId id="289" r:id="rId35"/>
+    <p:sldId id="290" r:id="rId36"/>
+    <p:sldId id="291" r:id="rId37"/>
   </p:sldIdLst>
-  <p:sldSz cx="12191695" cy="6858000" type="screen4x3"/>
+  <p:sldSz cx="12192000" cy="6858000"/>
   <p:notesSz cx="6858000" cy="9144000"/>
   <p:defaultTextStyle>
     <a:defPPr>
@@ -139,6 +139,22 @@
       </a:defRPr>
     </a:lvl9pPr>
   </p:defaultTextStyle>
+  <p:extLst>
+    <p:ext uri="{EFAFB233-063F-42B5-8137-9DF3F51BA10A}">
+      <p15:sldGuideLst xmlns:p15="http://schemas.microsoft.com/office/powerpoint/2012/main">
+        <p15:guide id="1" orient="horz" pos="2160">
+          <p15:clr>
+            <a:srgbClr val="A4A3A4"/>
+          </p15:clr>
+        </p15:guide>
+        <p15:guide id="2" pos="2880">
+          <p15:clr>
+            <a:srgbClr val="A4A3A4"/>
+          </p15:clr>
+        </p15:guide>
+      </p15:sldGuideLst>
+    </p:ext>
+  </p:extLst>
 </p:presentation>
 </file>
 
@@ -180,10 +196,9 @@
           <a:lstStyle/>
           <a:p>
             <a:r>
-              <a:rPr lang="en-US" smtClean="0"/>
+              <a:rPr lang="en-US"/>
               <a:t>Click to edit Master title style</a:t>
             </a:r>
-            <a:endParaRPr lang="en-US"/>
           </a:p>
         </p:txBody>
       </p:sp>
@@ -299,10 +314,9 @@
           </a:lstStyle>
           <a:p>
             <a:r>
-              <a:rPr lang="en-US" smtClean="0"/>
+              <a:rPr lang="en-US"/>
               <a:t>Click to edit Master subtitle style</a:t>
             </a:r>
-            <a:endParaRPr lang="en-US"/>
           </a:p>
         </p:txBody>
       </p:sp>
@@ -323,7 +337,7 @@
           <a:p>
             <a:fld id="{5BCAD085-E8A6-8845-BD4E-CB4CCA059FC4}" type="datetimeFigureOut">
               <a:rPr lang="en-US" smtClean="0"/>
-              <a:t>1/27/13</a:t>
+              <a:t>7/2/2026</a:t>
             </a:fld>
             <a:endParaRPr lang="en-US"/>
           </a:p>
@@ -417,10 +431,9 @@
           <a:lstStyle/>
           <a:p>
             <a:r>
-              <a:rPr lang="en-US" smtClean="0"/>
+              <a:rPr lang="en-US"/>
               <a:t>Click to edit Master title style</a:t>
             </a:r>
-            <a:endParaRPr lang="en-US"/>
           </a:p>
         </p:txBody>
       </p:sp>
@@ -441,38 +454,37 @@
           <a:p>
             <a:pPr lvl="0"/>
             <a:r>
-              <a:rPr lang="en-US" smtClean="0"/>
+              <a:rPr lang="en-US"/>
               <a:t>Click to edit Master text styles</a:t>
             </a:r>
           </a:p>
           <a:p>
             <a:pPr lvl="1"/>
             <a:r>
-              <a:rPr lang="en-US" smtClean="0"/>
+              <a:rPr lang="en-US"/>
               <a:t>Second level</a:t>
             </a:r>
           </a:p>
           <a:p>
             <a:pPr lvl="2"/>
             <a:r>
-              <a:rPr lang="en-US" smtClean="0"/>
+              <a:rPr lang="en-US"/>
               <a:t>Third level</a:t>
             </a:r>
           </a:p>
           <a:p>
             <a:pPr lvl="3"/>
             <a:r>
-              <a:rPr lang="en-US" smtClean="0"/>
+              <a:rPr lang="en-US"/>
               <a:t>Fourth level</a:t>
             </a:r>
           </a:p>
           <a:p>
             <a:pPr lvl="4"/>
             <a:r>
-              <a:rPr lang="en-US" smtClean="0"/>
+              <a:rPr lang="en-US"/>
               <a:t>Fifth level</a:t>
             </a:r>
-            <a:endParaRPr lang="en-US"/>
           </a:p>
         </p:txBody>
       </p:sp>
@@ -493,7 +505,7 @@
           <a:p>
             <a:fld id="{5BCAD085-E8A6-8845-BD4E-CB4CCA059FC4}" type="datetimeFigureOut">
               <a:rPr lang="en-US" smtClean="0"/>
-              <a:t>1/27/13</a:t>
+              <a:t>7/2/2026</a:t>
             </a:fld>
             <a:endParaRPr lang="en-US"/>
           </a:p>
@@ -592,10 +604,9 @@
           <a:lstStyle/>
           <a:p>
             <a:r>
-              <a:rPr lang="en-US" smtClean="0"/>
+              <a:rPr lang="en-US"/>
               <a:t>Click to edit Master title style</a:t>
             </a:r>
-            <a:endParaRPr lang="en-US"/>
           </a:p>
         </p:txBody>
       </p:sp>
@@ -621,38 +632,37 @@
           <a:p>
             <a:pPr lvl="0"/>
             <a:r>
-              <a:rPr lang="en-US" smtClean="0"/>
+              <a:rPr lang="en-US"/>
               <a:t>Click to edit Master text styles</a:t>
             </a:r>
           </a:p>
           <a:p>
             <a:pPr lvl="1"/>
             <a:r>
-              <a:rPr lang="en-US" smtClean="0"/>
+              <a:rPr lang="en-US"/>
               <a:t>Second level</a:t>
             </a:r>
           </a:p>
           <a:p>
             <a:pPr lvl="2"/>
             <a:r>
-              <a:rPr lang="en-US" smtClean="0"/>
+              <a:rPr lang="en-US"/>
               <a:t>Third level</a:t>
             </a:r>
           </a:p>
           <a:p>
             <a:pPr lvl="3"/>
             <a:r>
-              <a:rPr lang="en-US" smtClean="0"/>
+              <a:rPr lang="en-US"/>
               <a:t>Fourth level</a:t>
             </a:r>
           </a:p>
           <a:p>
             <a:pPr lvl="4"/>
             <a:r>
-              <a:rPr lang="en-US" smtClean="0"/>
+              <a:rPr lang="en-US"/>
               <a:t>Fifth level</a:t>
             </a:r>
-            <a:endParaRPr lang="en-US"/>
           </a:p>
         </p:txBody>
       </p:sp>
@@ -673,7 +683,7 @@
           <a:p>
             <a:fld id="{5BCAD085-E8A6-8845-BD4E-CB4CCA059FC4}" type="datetimeFigureOut">
               <a:rPr lang="en-US" smtClean="0"/>
-              <a:t>1/27/13</a:t>
+              <a:t>7/2/2026</a:t>
             </a:fld>
             <a:endParaRPr lang="en-US"/>
           </a:p>
@@ -767,10 +777,9 @@
           <a:lstStyle/>
           <a:p>
             <a:r>
-              <a:rPr lang="en-US" smtClean="0"/>
+              <a:rPr lang="en-US"/>
               <a:t>Click to edit Master title style</a:t>
             </a:r>
-            <a:endParaRPr lang="en-US"/>
           </a:p>
         </p:txBody>
       </p:sp>
@@ -791,38 +800,37 @@
           <a:p>
             <a:pPr lvl="0"/>
             <a:r>
-              <a:rPr lang="en-US" smtClean="0"/>
+              <a:rPr lang="en-US"/>
               <a:t>Click to edit Master text styles</a:t>
             </a:r>
           </a:p>
           <a:p>
             <a:pPr lvl="1"/>
             <a:r>
-              <a:rPr lang="en-US" smtClean="0"/>
+              <a:rPr lang="en-US"/>
               <a:t>Second level</a:t>
             </a:r>
           </a:p>
           <a:p>
             <a:pPr lvl="2"/>
             <a:r>
-              <a:rPr lang="en-US" smtClean="0"/>
+              <a:rPr lang="en-US"/>
               <a:t>Third level</a:t>
             </a:r>
           </a:p>
           <a:p>
             <a:pPr lvl="3"/>
             <a:r>
-              <a:rPr lang="en-US" smtClean="0"/>
+              <a:rPr lang="en-US"/>
               <a:t>Fourth level</a:t>
             </a:r>
           </a:p>
           <a:p>
             <a:pPr lvl="4"/>
             <a:r>
-              <a:rPr lang="en-US" smtClean="0"/>
+              <a:rPr lang="en-US"/>
               <a:t>Fifth level</a:t>
             </a:r>
-            <a:endParaRPr lang="en-US"/>
           </a:p>
         </p:txBody>
       </p:sp>
@@ -843,7 +851,7 @@
           <a:p>
             <a:fld id="{5BCAD085-E8A6-8845-BD4E-CB4CCA059FC4}" type="datetimeFigureOut">
               <a:rPr lang="en-US" smtClean="0"/>
-              <a:t>1/27/13</a:t>
+              <a:t>7/2/2026</a:t>
             </a:fld>
             <a:endParaRPr lang="en-US"/>
           </a:p>
@@ -946,10 +954,9 @@
           </a:lstStyle>
           <a:p>
             <a:r>
-              <a:rPr lang="en-US" smtClean="0"/>
+              <a:rPr lang="en-US"/>
               <a:t>Click to edit Master title style</a:t>
             </a:r>
-            <a:endParaRPr lang="en-US"/>
           </a:p>
         </p:txBody>
       </p:sp>
@@ -1066,7 +1073,7 @@
           <a:p>
             <a:pPr lvl="0"/>
             <a:r>
-              <a:rPr lang="en-US" smtClean="0"/>
+              <a:rPr lang="en-US"/>
               <a:t>Click to edit Master text styles</a:t>
             </a:r>
           </a:p>
@@ -1089,7 +1096,7 @@
           <a:p>
             <a:fld id="{5BCAD085-E8A6-8845-BD4E-CB4CCA059FC4}" type="datetimeFigureOut">
               <a:rPr lang="en-US" smtClean="0"/>
-              <a:t>1/27/13</a:t>
+              <a:t>7/2/2026</a:t>
             </a:fld>
             <a:endParaRPr lang="en-US"/>
           </a:p>
@@ -1183,10 +1190,9 @@
           <a:lstStyle/>
           <a:p>
             <a:r>
-              <a:rPr lang="en-US" smtClean="0"/>
+              <a:rPr lang="en-US"/>
               <a:t>Click to edit Master title style</a:t>
             </a:r>
-            <a:endParaRPr lang="en-US"/>
           </a:p>
         </p:txBody>
       </p:sp>
@@ -1240,38 +1246,37 @@
           <a:p>
             <a:pPr lvl="0"/>
             <a:r>
-              <a:rPr lang="en-US" smtClean="0"/>
+              <a:rPr lang="en-US"/>
               <a:t>Click to edit Master text styles</a:t>
             </a:r>
           </a:p>
           <a:p>
             <a:pPr lvl="1"/>
             <a:r>
-              <a:rPr lang="en-US" smtClean="0"/>
+              <a:rPr lang="en-US"/>
               <a:t>Second level</a:t>
             </a:r>
           </a:p>
           <a:p>
             <a:pPr lvl="2"/>
             <a:r>
-              <a:rPr lang="en-US" smtClean="0"/>
+              <a:rPr lang="en-US"/>
               <a:t>Third level</a:t>
             </a:r>
           </a:p>
           <a:p>
             <a:pPr lvl="3"/>
             <a:r>
-              <a:rPr lang="en-US" smtClean="0"/>
+              <a:rPr lang="en-US"/>
               <a:t>Fourth level</a:t>
             </a:r>
           </a:p>
           <a:p>
             <a:pPr lvl="4"/>
             <a:r>
-              <a:rPr lang="en-US" smtClean="0"/>
+              <a:rPr lang="en-US"/>
               <a:t>Fifth level</a:t>
             </a:r>
-            <a:endParaRPr lang="en-US"/>
           </a:p>
         </p:txBody>
       </p:sp>
@@ -1325,38 +1330,37 @@
           <a:p>
             <a:pPr lvl="0"/>
             <a:r>
-              <a:rPr lang="en-US" smtClean="0"/>
+              <a:rPr lang="en-US"/>
               <a:t>Click to edit Master text styles</a:t>
             </a:r>
           </a:p>
           <a:p>
             <a:pPr lvl="1"/>
             <a:r>
-              <a:rPr lang="en-US" smtClean="0"/>
+              <a:rPr lang="en-US"/>
               <a:t>Second level</a:t>
             </a:r>
           </a:p>
           <a:p>
             <a:pPr lvl="2"/>
             <a:r>
-              <a:rPr lang="en-US" smtClean="0"/>
+              <a:rPr lang="en-US"/>
               <a:t>Third level</a:t>
             </a:r>
           </a:p>
           <a:p>
             <a:pPr lvl="3"/>
             <a:r>
-              <a:rPr lang="en-US" smtClean="0"/>
+              <a:rPr lang="en-US"/>
               <a:t>Fourth level</a:t>
             </a:r>
           </a:p>
           <a:p>
             <a:pPr lvl="4"/>
             <a:r>
-              <a:rPr lang="en-US" smtClean="0"/>
+              <a:rPr lang="en-US"/>
               <a:t>Fifth level</a:t>
             </a:r>
-            <a:endParaRPr lang="en-US"/>
           </a:p>
         </p:txBody>
       </p:sp>
@@ -1377,7 +1381,7 @@
           <a:p>
             <a:fld id="{5BCAD085-E8A6-8845-BD4E-CB4CCA059FC4}" type="datetimeFigureOut">
               <a:rPr lang="en-US" smtClean="0"/>
-              <a:t>1/27/13</a:t>
+              <a:t>7/2/2026</a:t>
             </a:fld>
             <a:endParaRPr lang="en-US"/>
           </a:p>
@@ -1475,10 +1479,9 @@
           </a:lstStyle>
           <a:p>
             <a:r>
-              <a:rPr lang="en-US" smtClean="0"/>
+              <a:rPr lang="en-US"/>
               <a:t>Click to edit Master title style</a:t>
             </a:r>
-            <a:endParaRPr lang="en-US"/>
           </a:p>
         </p:txBody>
       </p:sp>
@@ -1541,7 +1544,7 @@
           <a:p>
             <a:pPr lvl="0"/>
             <a:r>
-              <a:rPr lang="en-US" smtClean="0"/>
+              <a:rPr lang="en-US"/>
               <a:t>Click to edit Master text styles</a:t>
             </a:r>
           </a:p>
@@ -1597,38 +1600,37 @@
           <a:p>
             <a:pPr lvl="0"/>
             <a:r>
-              <a:rPr lang="en-US" smtClean="0"/>
+              <a:rPr lang="en-US"/>
               <a:t>Click to edit Master text styles</a:t>
             </a:r>
           </a:p>
           <a:p>
             <a:pPr lvl="1"/>
             <a:r>
-              <a:rPr lang="en-US" smtClean="0"/>
+              <a:rPr lang="en-US"/>
               <a:t>Second level</a:t>
             </a:r>
           </a:p>
           <a:p>
             <a:pPr lvl="2"/>
             <a:r>
-              <a:rPr lang="en-US" smtClean="0"/>
+              <a:rPr lang="en-US"/>
               <a:t>Third level</a:t>
             </a:r>
           </a:p>
           <a:p>
             <a:pPr lvl="3"/>
             <a:r>
-              <a:rPr lang="en-US" smtClean="0"/>
+              <a:rPr lang="en-US"/>
               <a:t>Fourth level</a:t>
             </a:r>
           </a:p>
           <a:p>
             <a:pPr lvl="4"/>
             <a:r>
-              <a:rPr lang="en-US" smtClean="0"/>
+              <a:rPr lang="en-US"/>
               <a:t>Fifth level</a:t>
             </a:r>
-            <a:endParaRPr lang="en-US"/>
           </a:p>
         </p:txBody>
       </p:sp>
@@ -1691,7 +1693,7 @@
           <a:p>
             <a:pPr lvl="0"/>
             <a:r>
-              <a:rPr lang="en-US" smtClean="0"/>
+              <a:rPr lang="en-US"/>
               <a:t>Click to edit Master text styles</a:t>
             </a:r>
           </a:p>
@@ -1747,38 +1749,37 @@
           <a:p>
             <a:pPr lvl="0"/>
             <a:r>
-              <a:rPr lang="en-US" smtClean="0"/>
+              <a:rPr lang="en-US"/>
               <a:t>Click to edit Master text styles</a:t>
             </a:r>
           </a:p>
           <a:p>
             <a:pPr lvl="1"/>
             <a:r>
-              <a:rPr lang="en-US" smtClean="0"/>
+              <a:rPr lang="en-US"/>
               <a:t>Second level</a:t>
             </a:r>
           </a:p>
           <a:p>
             <a:pPr lvl="2"/>
             <a:r>
-              <a:rPr lang="en-US" smtClean="0"/>
+              <a:rPr lang="en-US"/>
               <a:t>Third level</a:t>
             </a:r>
           </a:p>
           <a:p>
             <a:pPr lvl="3"/>
             <a:r>
-              <a:rPr lang="en-US" smtClean="0"/>
+              <a:rPr lang="en-US"/>
               <a:t>Fourth level</a:t>
             </a:r>
           </a:p>
           <a:p>
             <a:pPr lvl="4"/>
             <a:r>
-              <a:rPr lang="en-US" smtClean="0"/>
+              <a:rPr lang="en-US"/>
               <a:t>Fifth level</a:t>
             </a:r>
-            <a:endParaRPr lang="en-US"/>
           </a:p>
         </p:txBody>
       </p:sp>
@@ -1799,7 +1800,7 @@
           <a:p>
             <a:fld id="{5BCAD085-E8A6-8845-BD4E-CB4CCA059FC4}" type="datetimeFigureOut">
               <a:rPr lang="en-US" smtClean="0"/>
-              <a:t>1/27/13</a:t>
+              <a:t>7/2/2026</a:t>
             </a:fld>
             <a:endParaRPr lang="en-US"/>
           </a:p>
@@ -1893,10 +1894,9 @@
           <a:lstStyle/>
           <a:p>
             <a:r>
-              <a:rPr lang="en-US" smtClean="0"/>
+              <a:rPr lang="en-US"/>
               <a:t>Click to edit Master title style</a:t>
             </a:r>
-            <a:endParaRPr lang="en-US"/>
           </a:p>
         </p:txBody>
       </p:sp>
@@ -1917,7 +1917,7 @@
           <a:p>
             <a:fld id="{5BCAD085-E8A6-8845-BD4E-CB4CCA059FC4}" type="datetimeFigureOut">
               <a:rPr lang="en-US" smtClean="0"/>
-              <a:t>1/27/13</a:t>
+              <a:t>7/2/2026</a:t>
             </a:fld>
             <a:endParaRPr lang="en-US"/>
           </a:p>
@@ -2012,7 +2012,7 @@
           <a:p>
             <a:fld id="{5BCAD085-E8A6-8845-BD4E-CB4CCA059FC4}" type="datetimeFigureOut">
               <a:rPr lang="en-US" smtClean="0"/>
-              <a:t>1/27/13</a:t>
+              <a:t>7/2/2026</a:t>
             </a:fld>
             <a:endParaRPr lang="en-US"/>
           </a:p>
@@ -2115,10 +2115,9 @@
           </a:lstStyle>
           <a:p>
             <a:r>
-              <a:rPr lang="en-US" smtClean="0"/>
+              <a:rPr lang="en-US"/>
               <a:t>Click to edit Master title style</a:t>
             </a:r>
-            <a:endParaRPr lang="en-US"/>
           </a:p>
         </p:txBody>
       </p:sp>
@@ -2172,38 +2171,37 @@
           <a:p>
             <a:pPr lvl="0"/>
             <a:r>
-              <a:rPr lang="en-US" smtClean="0"/>
+              <a:rPr lang="en-US"/>
               <a:t>Click to edit Master text styles</a:t>
             </a:r>
           </a:p>
           <a:p>
             <a:pPr lvl="1"/>
             <a:r>
-              <a:rPr lang="en-US" smtClean="0"/>
+              <a:rPr lang="en-US"/>
               <a:t>Second level</a:t>
             </a:r>
           </a:p>
           <a:p>
             <a:pPr lvl="2"/>
             <a:r>
-              <a:rPr lang="en-US" smtClean="0"/>
+              <a:rPr lang="en-US"/>
               <a:t>Third level</a:t>
             </a:r>
           </a:p>
           <a:p>
             <a:pPr lvl="3"/>
             <a:r>
-              <a:rPr lang="en-US" smtClean="0"/>
+              <a:rPr lang="en-US"/>
               <a:t>Fourth level</a:t>
             </a:r>
           </a:p>
           <a:p>
             <a:pPr lvl="4"/>
             <a:r>
-              <a:rPr lang="en-US" smtClean="0"/>
+              <a:rPr lang="en-US"/>
               <a:t>Fifth level</a:t>
             </a:r>
-            <a:endParaRPr lang="en-US"/>
           </a:p>
         </p:txBody>
       </p:sp>
@@ -2266,7 +2264,7 @@
           <a:p>
             <a:pPr lvl="0"/>
             <a:r>
-              <a:rPr lang="en-US" smtClean="0"/>
+              <a:rPr lang="en-US"/>
               <a:t>Click to edit Master text styles</a:t>
             </a:r>
           </a:p>
@@ -2289,7 +2287,7 @@
           <a:p>
             <a:fld id="{5BCAD085-E8A6-8845-BD4E-CB4CCA059FC4}" type="datetimeFigureOut">
               <a:rPr lang="en-US" smtClean="0"/>
-              <a:t>1/27/13</a:t>
+              <a:t>7/2/2026</a:t>
             </a:fld>
             <a:endParaRPr lang="en-US"/>
           </a:p>
@@ -2392,10 +2390,9 @@
           </a:lstStyle>
           <a:p>
             <a:r>
-              <a:rPr lang="en-US" smtClean="0"/>
+              <a:rPr lang="en-US"/>
               <a:t>Click to edit Master title style</a:t>
             </a:r>
-            <a:endParaRPr lang="en-US"/>
           </a:p>
         </p:txBody>
       </p:sp>
@@ -2519,7 +2516,7 @@
           <a:p>
             <a:pPr lvl="0"/>
             <a:r>
-              <a:rPr lang="en-US" smtClean="0"/>
+              <a:rPr lang="en-US"/>
               <a:t>Click to edit Master text styles</a:t>
             </a:r>
           </a:p>
@@ -2542,7 +2539,7 @@
           <a:p>
             <a:fld id="{5BCAD085-E8A6-8845-BD4E-CB4CCA059FC4}" type="datetimeFigureOut">
               <a:rPr lang="en-US" smtClean="0"/>
-              <a:t>1/27/13</a:t>
+              <a:t>7/2/2026</a:t>
             </a:fld>
             <a:endParaRPr lang="en-US"/>
           </a:p>
@@ -2651,10 +2648,9 @@
           <a:lstStyle/>
           <a:p>
             <a:r>
-              <a:rPr lang="en-US" smtClean="0"/>
+              <a:rPr lang="en-US"/>
               <a:t>Click to edit Master title style</a:t>
             </a:r>
-            <a:endParaRPr lang="en-US"/>
           </a:p>
         </p:txBody>
       </p:sp>
@@ -2685,38 +2681,37 @@
           <a:p>
             <a:pPr lvl="0"/>
             <a:r>
-              <a:rPr lang="en-US" smtClean="0"/>
+              <a:rPr lang="en-US"/>
               <a:t>Click to edit Master text styles</a:t>
             </a:r>
           </a:p>
           <a:p>
             <a:pPr lvl="1"/>
             <a:r>
-              <a:rPr lang="en-US" smtClean="0"/>
+              <a:rPr lang="en-US"/>
               <a:t>Second level</a:t>
             </a:r>
           </a:p>
           <a:p>
             <a:pPr lvl="2"/>
             <a:r>
-              <a:rPr lang="en-US" smtClean="0"/>
+              <a:rPr lang="en-US"/>
               <a:t>Third level</a:t>
             </a:r>
           </a:p>
           <a:p>
             <a:pPr lvl="3"/>
             <a:r>
-              <a:rPr lang="en-US" smtClean="0"/>
+              <a:rPr lang="en-US"/>
               <a:t>Fourth level</a:t>
             </a:r>
           </a:p>
           <a:p>
             <a:pPr lvl="4"/>
             <a:r>
-              <a:rPr lang="en-US" smtClean="0"/>
+              <a:rPr lang="en-US"/>
               <a:t>Fifth level</a:t>
             </a:r>
-            <a:endParaRPr lang="en-US"/>
           </a:p>
         </p:txBody>
       </p:sp>
@@ -2755,7 +2750,7 @@
           <a:p>
             <a:fld id="{5BCAD085-E8A6-8845-BD4E-CB4CCA059FC4}" type="datetimeFigureOut">
               <a:rPr lang="en-US" smtClean="0"/>
-              <a:t>1/27/13</a:t>
+              <a:t>7/2/2026</a:t>
             </a:fld>
             <a:endParaRPr lang="en-US"/>
           </a:p>
@@ -3114,7 +3109,7 @@
 </file>
 
 <file path=ppt/slides/slide1.xml><?xml version="1.0" encoding="utf-8"?>
-<p:sld xmlns:a="http://schemas.openxmlformats.org/drawingml/2006/main" xmlns:p="http://schemas.openxmlformats.org/presentationml/2006/main" xmlns:r="http://schemas.openxmlformats.org/officeDocument/2006/relationships">
+<p:sld xmlns:a="http://schemas.openxmlformats.org/drawingml/2006/main" xmlns:r="http://schemas.openxmlformats.org/officeDocument/2006/relationships" xmlns:p="http://schemas.openxmlformats.org/presentationml/2006/main">
   <p:cSld>
     <p:bg>
       <p:bgPr>
@@ -3130,7 +3125,14 @@
         <p:cNvGrpSpPr/>
         <p:nvPr/>
       </p:nvGrpSpPr>
-      <p:grpSpPr/>
+      <p:grpSpPr>
+        <a:xfrm>
+          <a:off x="0" y="0"/>
+          <a:ext cx="0" cy="0"/>
+          <a:chOff x="0" y="0"/>
+          <a:chExt cx="0" cy="0"/>
+        </a:xfrm>
+      </p:grpSpPr>
       <p:sp>
         <p:nvSpPr>
           <p:cNvPr id="2" name="Rounded Rectangle 1"/>
@@ -3167,7 +3169,7 @@
           </a:fontRef>
         </p:style>
         <p:txBody>
-          <a:bodyPr rtlCol="0" anchor="ctr" wrap="square" lIns="731520" tIns="457200"/>
+          <a:bodyPr wrap="square" lIns="731520" tIns="457200" rtlCol="0" anchor="ctr"/>
           <a:lstStyle/>
           <a:p>
             <a:pPr algn="ctr">
@@ -3179,6 +3181,7 @@
               </a:defRPr>
             </a:pPr>
             <a:r>
+              <a:rPr dirty="0"/>
               <a:t>BUAHSAFE: DEEP DIVE PIPELINE &amp; MASTER WALKTHROUGH</a:t>
             </a:r>
           </a:p>
@@ -3195,11 +3198,103 @@
               </a:defRPr>
             </a:pPr>
             <a:r>
-              <a:t>Panduan Ekstensif 36 Slide Membedah Tuntas First Principles, Teori Statistik &amp; Algoritma,</a:t>
-            </a:r>
-            <a:br/>
-            <a:r>
-              <a:t>EDA, Matriks Korelasi, Preprocessing, hingga Evaluasi Komprehensif Seluruh Model</a:t>
+              <a:rPr dirty="0"/>
+              <a:t>Panduan </a:t>
+            </a:r>
+            <a:r>
+              <a:rPr dirty="0" err="1"/>
+              <a:t>Ekstensif</a:t>
+            </a:r>
+            <a:r>
+              <a:rPr dirty="0"/>
+              <a:t> 36 Slide </a:t>
+            </a:r>
+            <a:r>
+              <a:rPr dirty="0" err="1"/>
+              <a:t>Membedah</a:t>
+            </a:r>
+            <a:r>
+              <a:rPr dirty="0"/>
+              <a:t> </a:t>
+            </a:r>
+            <a:r>
+              <a:rPr dirty="0" err="1"/>
+              <a:t>Tuntas</a:t>
+            </a:r>
+            <a:r>
+              <a:rPr dirty="0"/>
+              <a:t> First Principles, Teori </a:t>
+            </a:r>
+            <a:r>
+              <a:rPr dirty="0" err="1"/>
+              <a:t>Statistik</a:t>
+            </a:r>
+            <a:r>
+              <a:rPr dirty="0"/>
+              <a:t> &amp; </a:t>
+            </a:r>
+            <a:r>
+              <a:rPr dirty="0" err="1"/>
+              <a:t>Algoritma</a:t>
+            </a:r>
+            <a:r>
+              <a:rPr dirty="0"/>
+              <a:t>,</a:t>
+            </a:r>
+            <a:br>
+              <a:rPr dirty="0"/>
+            </a:br>
+            <a:r>
+              <a:rPr dirty="0"/>
+              <a:t>EDA, </a:t>
+            </a:r>
+            <a:r>
+              <a:rPr dirty="0" err="1"/>
+              <a:t>Matriks</a:t>
+            </a:r>
+            <a:r>
+              <a:rPr dirty="0"/>
+              <a:t> </a:t>
+            </a:r>
+            <a:r>
+              <a:rPr dirty="0" err="1"/>
+              <a:t>Korelasi</a:t>
+            </a:r>
+            <a:r>
+              <a:rPr dirty="0"/>
+              <a:t>, Preprocessing, </a:t>
+            </a:r>
+            <a:r>
+              <a:rPr dirty="0" err="1"/>
+              <a:t>hingga</a:t>
+            </a:r>
+            <a:r>
+              <a:rPr dirty="0"/>
+              <a:t> </a:t>
+            </a:r>
+            <a:r>
+              <a:rPr dirty="0" err="1"/>
+              <a:t>Evaluasi</a:t>
+            </a:r>
+            <a:r>
+              <a:rPr dirty="0"/>
+              <a:t> </a:t>
+            </a:r>
+            <a:r>
+              <a:rPr dirty="0" err="1"/>
+              <a:t>Komprehensif</a:t>
+            </a:r>
+            <a:r>
+              <a:rPr dirty="0"/>
+              <a:t> </a:t>
+            </a:r>
+            <a:r>
+              <a:rPr dirty="0" err="1"/>
+              <a:t>Seluruh</a:t>
+            </a:r>
+            <a:r>
+              <a:rPr dirty="0"/>
+              <a:t> Model</a:t>
             </a:r>
           </a:p>
           <a:p>
@@ -3215,11 +3310,95 @@
               </a:defRPr>
             </a:pPr>
             <a:r>
-              <a:t>Dilengkapi Landasan Teori Metrik (Recall vs Accuracy), Kausalitas Pembagian Dataset,</a:t>
-            </a:r>
-            <a:br/>
-            <a:r>
-              <a:t>Analisis ANOVA vs Permutation, serta Bedah Tuntas 15 Pertanyaan Refleksi Tim.</a:t>
+              <a:rPr dirty="0" err="1"/>
+              <a:t>Dilengkapi</a:t>
+            </a:r>
+            <a:r>
+              <a:rPr dirty="0"/>
+              <a:t> </a:t>
+            </a:r>
+            <a:r>
+              <a:rPr dirty="0" err="1"/>
+              <a:t>Landasan</a:t>
+            </a:r>
+            <a:r>
+              <a:rPr dirty="0"/>
+              <a:t> Teori </a:t>
+            </a:r>
+            <a:r>
+              <a:rPr dirty="0" err="1"/>
+              <a:t>Metrik</a:t>
+            </a:r>
+            <a:r>
+              <a:rPr dirty="0"/>
+              <a:t> (Recall vs Accuracy), </a:t>
+            </a:r>
+            <a:r>
+              <a:rPr dirty="0" err="1"/>
+              <a:t>Kausalitas</a:t>
+            </a:r>
+            <a:r>
+              <a:rPr dirty="0"/>
+              <a:t> </a:t>
+            </a:r>
+            <a:r>
+              <a:rPr dirty="0" err="1"/>
+              <a:t>Pembagian</a:t>
+            </a:r>
+            <a:r>
+              <a:rPr dirty="0"/>
+              <a:t> Dataset,</a:t>
+            </a:r>
+            <a:br>
+              <a:rPr dirty="0"/>
+            </a:br>
+            <a:r>
+              <a:rPr dirty="0" err="1"/>
+              <a:t>Analisis</a:t>
+            </a:r>
+            <a:r>
+              <a:rPr dirty="0"/>
+              <a:t> ANOVA vs Permutation, </a:t>
+            </a:r>
+            <a:r>
+              <a:rPr dirty="0" err="1"/>
+              <a:t>serta</a:t>
+            </a:r>
+            <a:r>
+              <a:rPr dirty="0"/>
+              <a:t> </a:t>
+            </a:r>
+            <a:r>
+              <a:rPr dirty="0" err="1"/>
+              <a:t>Bedah</a:t>
+            </a:r>
+            <a:r>
+              <a:rPr dirty="0"/>
+              <a:t> </a:t>
+            </a:r>
+            <a:r>
+              <a:rPr dirty="0" err="1"/>
+              <a:t>Tuntas</a:t>
+            </a:r>
+            <a:r>
+              <a:rPr dirty="0"/>
+              <a:t> 15 </a:t>
+            </a:r>
+            <a:r>
+              <a:rPr dirty="0" err="1"/>
+              <a:t>Pertanyaan</a:t>
+            </a:r>
+            <a:r>
+              <a:rPr dirty="0"/>
+              <a:t> </a:t>
+            </a:r>
+            <a:r>
+              <a:rPr dirty="0" err="1"/>
+              <a:t>Refleksi</a:t>
+            </a:r>
+            <a:r>
+              <a:rPr dirty="0"/>
+              <a:t> Tim.</a:t>
             </a:r>
           </a:p>
           <a:p>
@@ -3235,8 +3414,74 @@
               </a:defRPr>
             </a:pPr>
             <a:r>
-              <a:t>Disusun secara Presisi Menggunakan Grafik Otentik Notebook Tanpa Overlap atau Redundansi</a:t>
-            </a:r>
+              <a:rPr dirty="0" err="1"/>
+              <a:t>Disusun</a:t>
+            </a:r>
+            <a:r>
+              <a:rPr dirty="0"/>
+              <a:t> </a:t>
+            </a:r>
+            <a:r>
+              <a:rPr dirty="0" err="1"/>
+              <a:t>secara</a:t>
+            </a:r>
+            <a:r>
+              <a:rPr dirty="0"/>
+              <a:t> </a:t>
+            </a:r>
+            <a:r>
+              <a:rPr dirty="0" err="1"/>
+              <a:t>Presisi</a:t>
+            </a:r>
+            <a:r>
+              <a:rPr dirty="0"/>
+              <a:t> </a:t>
+            </a:r>
+            <a:r>
+              <a:rPr dirty="0" err="1"/>
+              <a:t>Menggunakan</a:t>
+            </a:r>
+            <a:r>
+              <a:rPr dirty="0"/>
+              <a:t> </a:t>
+            </a:r>
+            <a:r>
+              <a:rPr dirty="0" err="1"/>
+              <a:t>Grafik</a:t>
+            </a:r>
+            <a:r>
+              <a:rPr dirty="0"/>
+              <a:t> </a:t>
+            </a:r>
+            <a:r>
+              <a:rPr dirty="0" err="1"/>
+              <a:t>Otentik</a:t>
+            </a:r>
+            <a:r>
+              <a:rPr dirty="0"/>
+              <a:t> Notebook </a:t>
+            </a:r>
+            <a:r>
+              <a:rPr dirty="0" err="1"/>
+              <a:t>Tanpa</a:t>
+            </a:r>
+            <a:r>
+              <a:rPr dirty="0"/>
+              <a:t> Overlap </a:t>
+            </a:r>
+            <a:r>
+              <a:rPr dirty="0" err="1"/>
+              <a:t>atau</a:t>
+            </a:r>
+            <a:r>
+              <a:rPr dirty="0"/>
+              <a:t> </a:t>
+            </a:r>
+            <a:r>
+              <a:rPr dirty="0" err="1"/>
+              <a:t>Redundansi</a:t>
+            </a:r>
+            <a:endParaRPr dirty="0"/>
           </a:p>
         </p:txBody>
       </p:sp>
@@ -3249,7 +3494,7 @@
 </file>
 
 <file path=ppt/slides/slide10.xml><?xml version="1.0" encoding="utf-8"?>
-<p:sld xmlns:a="http://schemas.openxmlformats.org/drawingml/2006/main" xmlns:p="http://schemas.openxmlformats.org/presentationml/2006/main" xmlns:r="http://schemas.openxmlformats.org/officeDocument/2006/relationships">
+<p:sld xmlns:a="http://schemas.openxmlformats.org/drawingml/2006/main" xmlns:r="http://schemas.openxmlformats.org/officeDocument/2006/relationships" xmlns:p="http://schemas.openxmlformats.org/presentationml/2006/main">
   <p:cSld>
     <p:bg>
       <p:bgPr>
@@ -3265,7 +3510,14 @@
         <p:cNvGrpSpPr/>
         <p:nvPr/>
       </p:nvGrpSpPr>
-      <p:grpSpPr/>
+      <p:grpSpPr>
+        <a:xfrm>
+          <a:off x="0" y="0"/>
+          <a:ext cx="0" cy="0"/>
+          <a:chOff x="0" y="0"/>
+          <a:chExt cx="0" cy="0"/>
+        </a:xfrm>
+      </p:grpSpPr>
       <p:sp>
         <p:nvSpPr>
           <p:cNvPr id="2" name="Rectangle 1"/>
@@ -3302,7 +3554,7 @@
           </a:fontRef>
         </p:style>
         <p:txBody>
-          <a:bodyPr rtlCol="0" anchor="ctr" wrap="square" lIns="457200" tIns="137160"/>
+          <a:bodyPr wrap="square" lIns="457200" tIns="137160" rtlCol="0" anchor="ctr"/>
           <a:lstStyle/>
           <a:p>
             <a:pPr algn="ctr">
@@ -3434,6 +3686,7 @@
           <a:lstStyle/>
           <a:p>
             <a:pPr algn="ctr"/>
+            <a:endParaRPr/>
           </a:p>
         </p:txBody>
       </p:sp>
@@ -3473,7 +3726,7 @@
           </a:fontRef>
         </p:style>
         <p:txBody>
-          <a:bodyPr rtlCol="0" anchor="ctr" lIns="182880" tIns="91440"/>
+          <a:bodyPr lIns="182880" tIns="91440" rtlCol="0" anchor="ctr"/>
           <a:lstStyle/>
           <a:p>
             <a:pPr algn="ctr">
@@ -3587,7 +3840,7 @@
 </file>
 
 <file path=ppt/slides/slide11.xml><?xml version="1.0" encoding="utf-8"?>
-<p:sld xmlns:a="http://schemas.openxmlformats.org/drawingml/2006/main" xmlns:p="http://schemas.openxmlformats.org/presentationml/2006/main" xmlns:r="http://schemas.openxmlformats.org/officeDocument/2006/relationships">
+<p:sld xmlns:a="http://schemas.openxmlformats.org/drawingml/2006/main" xmlns:r="http://schemas.openxmlformats.org/officeDocument/2006/relationships" xmlns:p="http://schemas.openxmlformats.org/presentationml/2006/main">
   <p:cSld>
     <p:bg>
       <p:bgPr>
@@ -3603,7 +3856,14 @@
         <p:cNvGrpSpPr/>
         <p:nvPr/>
       </p:nvGrpSpPr>
-      <p:grpSpPr/>
+      <p:grpSpPr>
+        <a:xfrm>
+          <a:off x="0" y="0"/>
+          <a:ext cx="0" cy="0"/>
+          <a:chOff x="0" y="0"/>
+          <a:chExt cx="0" cy="0"/>
+        </a:xfrm>
+      </p:grpSpPr>
       <p:sp>
         <p:nvSpPr>
           <p:cNvPr id="2" name="Rectangle 1"/>
@@ -3640,7 +3900,7 @@
           </a:fontRef>
         </p:style>
         <p:txBody>
-          <a:bodyPr rtlCol="0" anchor="ctr" wrap="square" lIns="457200" tIns="137160"/>
+          <a:bodyPr wrap="square" lIns="457200" tIns="137160" rtlCol="0" anchor="ctr"/>
           <a:lstStyle/>
           <a:p>
             <a:pPr algn="ctr">
@@ -3772,6 +4032,7 @@
           <a:lstStyle/>
           <a:p>
             <a:pPr algn="ctr"/>
+            <a:endParaRPr/>
           </a:p>
         </p:txBody>
       </p:sp>
@@ -3811,7 +4072,7 @@
           </a:fontRef>
         </p:style>
         <p:txBody>
-          <a:bodyPr rtlCol="0" anchor="ctr" lIns="182880" tIns="91440"/>
+          <a:bodyPr lIns="182880" tIns="91440" rtlCol="0" anchor="ctr"/>
           <a:lstStyle/>
           <a:p>
             <a:pPr algn="ctr">
@@ -3897,7 +4158,7 @@
 </file>
 
 <file path=ppt/slides/slide12.xml><?xml version="1.0" encoding="utf-8"?>
-<p:sld xmlns:a="http://schemas.openxmlformats.org/drawingml/2006/main" xmlns:p="http://schemas.openxmlformats.org/presentationml/2006/main" xmlns:r="http://schemas.openxmlformats.org/officeDocument/2006/relationships">
+<p:sld xmlns:a="http://schemas.openxmlformats.org/drawingml/2006/main" xmlns:r="http://schemas.openxmlformats.org/officeDocument/2006/relationships" xmlns:p="http://schemas.openxmlformats.org/presentationml/2006/main">
   <p:cSld>
     <p:bg>
       <p:bgPr>
@@ -3913,7 +4174,14 @@
         <p:cNvGrpSpPr/>
         <p:nvPr/>
       </p:nvGrpSpPr>
-      <p:grpSpPr/>
+      <p:grpSpPr>
+        <a:xfrm>
+          <a:off x="0" y="0"/>
+          <a:ext cx="0" cy="0"/>
+          <a:chOff x="0" y="0"/>
+          <a:chExt cx="0" cy="0"/>
+        </a:xfrm>
+      </p:grpSpPr>
       <p:sp>
         <p:nvSpPr>
           <p:cNvPr id="2" name="Rectangle 1"/>
@@ -3950,7 +4218,7 @@
           </a:fontRef>
         </p:style>
         <p:txBody>
-          <a:bodyPr rtlCol="0" anchor="ctr" wrap="square" lIns="457200" tIns="137160"/>
+          <a:bodyPr wrap="square" lIns="457200" tIns="137160" rtlCol="0" anchor="ctr"/>
           <a:lstStyle/>
           <a:p>
             <a:pPr algn="ctr">
@@ -4058,6 +4326,7 @@
           <a:lstStyle/>
           <a:p>
             <a:pPr algn="ctr"/>
+            <a:endParaRPr/>
           </a:p>
         </p:txBody>
       </p:sp>
@@ -4097,7 +4366,7 @@
           </a:fontRef>
         </p:style>
         <p:txBody>
-          <a:bodyPr rtlCol="0" anchor="ctr" lIns="182880" tIns="91440"/>
+          <a:bodyPr lIns="182880" tIns="91440" rtlCol="0" anchor="ctr"/>
           <a:lstStyle/>
           <a:p>
             <a:pPr algn="ctr">
@@ -4224,6 +4493,7 @@
           <a:lstStyle/>
           <a:p>
             <a:pPr algn="ctr"/>
+            <a:endParaRPr/>
           </a:p>
         </p:txBody>
       </p:sp>
@@ -4263,7 +4533,7 @@
           </a:fontRef>
         </p:style>
         <p:txBody>
-          <a:bodyPr rtlCol="0" anchor="ctr" lIns="182880" tIns="91440"/>
+          <a:bodyPr lIns="182880" tIns="91440" rtlCol="0" anchor="ctr"/>
           <a:lstStyle/>
           <a:p>
             <a:pPr algn="ctr">
@@ -4369,7 +4639,7 @@
 </file>
 
 <file path=ppt/slides/slide13.xml><?xml version="1.0" encoding="utf-8"?>
-<p:sld xmlns:a="http://schemas.openxmlformats.org/drawingml/2006/main" xmlns:p="http://schemas.openxmlformats.org/presentationml/2006/main" xmlns:r="http://schemas.openxmlformats.org/officeDocument/2006/relationships">
+<p:sld xmlns:a="http://schemas.openxmlformats.org/drawingml/2006/main" xmlns:r="http://schemas.openxmlformats.org/officeDocument/2006/relationships" xmlns:p="http://schemas.openxmlformats.org/presentationml/2006/main">
   <p:cSld>
     <p:bg>
       <p:bgPr>
@@ -4385,7 +4655,14 @@
         <p:cNvGrpSpPr/>
         <p:nvPr/>
       </p:nvGrpSpPr>
-      <p:grpSpPr/>
+      <p:grpSpPr>
+        <a:xfrm>
+          <a:off x="0" y="0"/>
+          <a:ext cx="0" cy="0"/>
+          <a:chOff x="0" y="0"/>
+          <a:chExt cx="0" cy="0"/>
+        </a:xfrm>
+      </p:grpSpPr>
       <p:sp>
         <p:nvSpPr>
           <p:cNvPr id="2" name="Rectangle 1"/>
@@ -4422,7 +4699,7 @@
           </a:fontRef>
         </p:style>
         <p:txBody>
-          <a:bodyPr rtlCol="0" anchor="ctr" wrap="square" lIns="457200" tIns="137160"/>
+          <a:bodyPr wrap="square" lIns="457200" tIns="137160" rtlCol="0" anchor="ctr"/>
           <a:lstStyle/>
           <a:p>
             <a:pPr algn="ctr">
@@ -4554,6 +4831,7 @@
           <a:lstStyle/>
           <a:p>
             <a:pPr algn="ctr"/>
+            <a:endParaRPr/>
           </a:p>
         </p:txBody>
       </p:sp>
@@ -4593,7 +4871,7 @@
           </a:fontRef>
         </p:style>
         <p:txBody>
-          <a:bodyPr rtlCol="0" anchor="ctr" lIns="182880" tIns="91440"/>
+          <a:bodyPr lIns="182880" tIns="91440" rtlCol="0" anchor="ctr"/>
           <a:lstStyle/>
           <a:p>
             <a:pPr algn="ctr">
@@ -4699,7 +4977,7 @@
 </file>
 
 <file path=ppt/slides/slide14.xml><?xml version="1.0" encoding="utf-8"?>
-<p:sld xmlns:a="http://schemas.openxmlformats.org/drawingml/2006/main" xmlns:p="http://schemas.openxmlformats.org/presentationml/2006/main" xmlns:r="http://schemas.openxmlformats.org/officeDocument/2006/relationships">
+<p:sld xmlns:a="http://schemas.openxmlformats.org/drawingml/2006/main" xmlns:r="http://schemas.openxmlformats.org/officeDocument/2006/relationships" xmlns:p="http://schemas.openxmlformats.org/presentationml/2006/main">
   <p:cSld>
     <p:bg>
       <p:bgPr>
@@ -4715,7 +4993,14 @@
         <p:cNvGrpSpPr/>
         <p:nvPr/>
       </p:nvGrpSpPr>
-      <p:grpSpPr/>
+      <p:grpSpPr>
+        <a:xfrm>
+          <a:off x="0" y="0"/>
+          <a:ext cx="0" cy="0"/>
+          <a:chOff x="0" y="0"/>
+          <a:chExt cx="0" cy="0"/>
+        </a:xfrm>
+      </p:grpSpPr>
       <p:sp>
         <p:nvSpPr>
           <p:cNvPr id="2" name="Rectangle 1"/>
@@ -4752,7 +5037,7 @@
           </a:fontRef>
         </p:style>
         <p:txBody>
-          <a:bodyPr rtlCol="0" anchor="ctr" wrap="square" lIns="457200" tIns="137160"/>
+          <a:bodyPr wrap="square" lIns="457200" tIns="137160" rtlCol="0" anchor="ctr"/>
           <a:lstStyle/>
           <a:p>
             <a:pPr algn="ctr">
@@ -4884,6 +5169,7 @@
           <a:lstStyle/>
           <a:p>
             <a:pPr algn="ctr"/>
+            <a:endParaRPr/>
           </a:p>
         </p:txBody>
       </p:sp>
@@ -4923,7 +5209,7 @@
           </a:fontRef>
         </p:style>
         <p:txBody>
-          <a:bodyPr rtlCol="0" anchor="ctr" lIns="182880" tIns="91440"/>
+          <a:bodyPr lIns="182880" tIns="91440" rtlCol="0" anchor="ctr"/>
           <a:lstStyle/>
           <a:p>
             <a:pPr algn="ctr">
@@ -5029,7 +5315,7 @@
 </file>
 
 <file path=ppt/slides/slide15.xml><?xml version="1.0" encoding="utf-8"?>
-<p:sld xmlns:a="http://schemas.openxmlformats.org/drawingml/2006/main" xmlns:p="http://schemas.openxmlformats.org/presentationml/2006/main" xmlns:r="http://schemas.openxmlformats.org/officeDocument/2006/relationships">
+<p:sld xmlns:a="http://schemas.openxmlformats.org/drawingml/2006/main" xmlns:r="http://schemas.openxmlformats.org/officeDocument/2006/relationships" xmlns:p="http://schemas.openxmlformats.org/presentationml/2006/main">
   <p:cSld>
     <p:bg>
       <p:bgPr>
@@ -5045,7 +5331,14 @@
         <p:cNvGrpSpPr/>
         <p:nvPr/>
       </p:nvGrpSpPr>
-      <p:grpSpPr/>
+      <p:grpSpPr>
+        <a:xfrm>
+          <a:off x="0" y="0"/>
+          <a:ext cx="0" cy="0"/>
+          <a:chOff x="0" y="0"/>
+          <a:chExt cx="0" cy="0"/>
+        </a:xfrm>
+      </p:grpSpPr>
       <p:sp>
         <p:nvSpPr>
           <p:cNvPr id="2" name="Rectangle 1"/>
@@ -5082,7 +5375,7 @@
           </a:fontRef>
         </p:style>
         <p:txBody>
-          <a:bodyPr rtlCol="0" anchor="ctr" wrap="square" lIns="457200" tIns="137160"/>
+          <a:bodyPr wrap="square" lIns="457200" tIns="137160" rtlCol="0" anchor="ctr"/>
           <a:lstStyle/>
           <a:p>
             <a:pPr algn="ctr">
@@ -5190,6 +5483,7 @@
           <a:lstStyle/>
           <a:p>
             <a:pPr algn="ctr"/>
+            <a:endParaRPr/>
           </a:p>
         </p:txBody>
       </p:sp>
@@ -5229,7 +5523,7 @@
           </a:fontRef>
         </p:style>
         <p:txBody>
-          <a:bodyPr rtlCol="0" anchor="ctr" lIns="182880" tIns="91440"/>
+          <a:bodyPr lIns="182880" tIns="91440" rtlCol="0" anchor="ctr"/>
           <a:lstStyle/>
           <a:p>
             <a:pPr algn="ctr">
@@ -5388,6 +5682,7 @@
           <a:lstStyle/>
           <a:p>
             <a:pPr algn="ctr"/>
+            <a:endParaRPr/>
           </a:p>
         </p:txBody>
       </p:sp>
@@ -5427,7 +5722,7 @@
           </a:fontRef>
         </p:style>
         <p:txBody>
-          <a:bodyPr rtlCol="0" anchor="ctr" lIns="182880" tIns="91440"/>
+          <a:bodyPr lIns="182880" tIns="91440" rtlCol="0" anchor="ctr"/>
           <a:lstStyle/>
           <a:p>
             <a:pPr algn="ctr">
@@ -5553,7 +5848,7 @@
 </file>
 
 <file path=ppt/slides/slide16.xml><?xml version="1.0" encoding="utf-8"?>
-<p:sld xmlns:a="http://schemas.openxmlformats.org/drawingml/2006/main" xmlns:p="http://schemas.openxmlformats.org/presentationml/2006/main" xmlns:r="http://schemas.openxmlformats.org/officeDocument/2006/relationships">
+<p:sld xmlns:a="http://schemas.openxmlformats.org/drawingml/2006/main" xmlns:r="http://schemas.openxmlformats.org/officeDocument/2006/relationships" xmlns:p="http://schemas.openxmlformats.org/presentationml/2006/main">
   <p:cSld>
     <p:bg>
       <p:bgPr>
@@ -5569,7 +5864,14 @@
         <p:cNvGrpSpPr/>
         <p:nvPr/>
       </p:nvGrpSpPr>
-      <p:grpSpPr/>
+      <p:grpSpPr>
+        <a:xfrm>
+          <a:off x="0" y="0"/>
+          <a:ext cx="0" cy="0"/>
+          <a:chOff x="0" y="0"/>
+          <a:chExt cx="0" cy="0"/>
+        </a:xfrm>
+      </p:grpSpPr>
       <p:sp>
         <p:nvSpPr>
           <p:cNvPr id="2" name="Rectangle 1"/>
@@ -5606,7 +5908,7 @@
           </a:fontRef>
         </p:style>
         <p:txBody>
-          <a:bodyPr rtlCol="0" anchor="ctr" wrap="square" lIns="457200" tIns="137160"/>
+          <a:bodyPr wrap="square" lIns="457200" tIns="137160" rtlCol="0" anchor="ctr"/>
           <a:lstStyle/>
           <a:p>
             <a:pPr algn="ctr">
@@ -5714,6 +6016,7 @@
           <a:lstStyle/>
           <a:p>
             <a:pPr algn="ctr"/>
+            <a:endParaRPr/>
           </a:p>
         </p:txBody>
       </p:sp>
@@ -5753,7 +6056,7 @@
           </a:fontRef>
         </p:style>
         <p:txBody>
-          <a:bodyPr rtlCol="0" anchor="ctr" lIns="182880" tIns="91440"/>
+          <a:bodyPr lIns="182880" tIns="91440" rtlCol="0" anchor="ctr"/>
           <a:lstStyle/>
           <a:p>
             <a:pPr algn="ctr">
@@ -5892,6 +6195,7 @@
           <a:lstStyle/>
           <a:p>
             <a:pPr algn="ctr"/>
+            <a:endParaRPr/>
           </a:p>
         </p:txBody>
       </p:sp>
@@ -5931,7 +6235,7 @@
           </a:fontRef>
         </p:style>
         <p:txBody>
-          <a:bodyPr rtlCol="0" anchor="ctr" lIns="182880" tIns="91440"/>
+          <a:bodyPr lIns="182880" tIns="91440" rtlCol="0" anchor="ctr"/>
           <a:lstStyle/>
           <a:p>
             <a:pPr algn="ctr">
@@ -6041,7 +6345,7 @@
 </file>
 
 <file path=ppt/slides/slide17.xml><?xml version="1.0" encoding="utf-8"?>
-<p:sld xmlns:a="http://schemas.openxmlformats.org/drawingml/2006/main" xmlns:p="http://schemas.openxmlformats.org/presentationml/2006/main" xmlns:r="http://schemas.openxmlformats.org/officeDocument/2006/relationships">
+<p:sld xmlns:a="http://schemas.openxmlformats.org/drawingml/2006/main" xmlns:r="http://schemas.openxmlformats.org/officeDocument/2006/relationships" xmlns:p="http://schemas.openxmlformats.org/presentationml/2006/main">
   <p:cSld>
     <p:bg>
       <p:bgPr>
@@ -6057,7 +6361,14 @@
         <p:cNvGrpSpPr/>
         <p:nvPr/>
       </p:nvGrpSpPr>
-      <p:grpSpPr/>
+      <p:grpSpPr>
+        <a:xfrm>
+          <a:off x="0" y="0"/>
+          <a:ext cx="0" cy="0"/>
+          <a:chOff x="0" y="0"/>
+          <a:chExt cx="0" cy="0"/>
+        </a:xfrm>
+      </p:grpSpPr>
       <p:sp>
         <p:nvSpPr>
           <p:cNvPr id="2" name="Rectangle 1"/>
@@ -6094,7 +6405,7 @@
           </a:fontRef>
         </p:style>
         <p:txBody>
-          <a:bodyPr rtlCol="0" anchor="ctr" wrap="square" lIns="457200" tIns="137160"/>
+          <a:bodyPr wrap="square" lIns="457200" tIns="137160" rtlCol="0" anchor="ctr"/>
           <a:lstStyle/>
           <a:p>
             <a:pPr algn="ctr">
@@ -6202,6 +6513,7 @@
           <a:lstStyle/>
           <a:p>
             <a:pPr algn="ctr"/>
+            <a:endParaRPr/>
           </a:p>
         </p:txBody>
       </p:sp>
@@ -6241,7 +6553,7 @@
           </a:fontRef>
         </p:style>
         <p:txBody>
-          <a:bodyPr rtlCol="0" anchor="ctr" lIns="182880" tIns="91440"/>
+          <a:bodyPr lIns="182880" tIns="91440" rtlCol="0" anchor="ctr"/>
           <a:lstStyle/>
           <a:p>
             <a:pPr algn="ctr">
@@ -6360,6 +6672,7 @@
           <a:lstStyle/>
           <a:p>
             <a:pPr algn="ctr"/>
+            <a:endParaRPr/>
           </a:p>
         </p:txBody>
       </p:sp>
@@ -6399,7 +6712,7 @@
           </a:fontRef>
         </p:style>
         <p:txBody>
-          <a:bodyPr rtlCol="0" anchor="ctr" lIns="182880" tIns="91440"/>
+          <a:bodyPr lIns="182880" tIns="91440" rtlCol="0" anchor="ctr"/>
           <a:lstStyle/>
           <a:p>
             <a:pPr algn="ctr">
@@ -6538,6 +6851,7 @@
           <a:lstStyle/>
           <a:p>
             <a:pPr algn="ctr"/>
+            <a:endParaRPr/>
           </a:p>
         </p:txBody>
       </p:sp>
@@ -6577,7 +6891,7 @@
           </a:fontRef>
         </p:style>
         <p:txBody>
-          <a:bodyPr rtlCol="0" anchor="ctr" lIns="182880" tIns="91440"/>
+          <a:bodyPr lIns="182880" tIns="91440" rtlCol="0" anchor="ctr"/>
           <a:lstStyle/>
           <a:p>
             <a:pPr algn="ctr">
@@ -6683,7 +6997,7 @@
 </file>
 
 <file path=ppt/slides/slide18.xml><?xml version="1.0" encoding="utf-8"?>
-<p:sld xmlns:a="http://schemas.openxmlformats.org/drawingml/2006/main" xmlns:p="http://schemas.openxmlformats.org/presentationml/2006/main" xmlns:r="http://schemas.openxmlformats.org/officeDocument/2006/relationships">
+<p:sld xmlns:a="http://schemas.openxmlformats.org/drawingml/2006/main" xmlns:r="http://schemas.openxmlformats.org/officeDocument/2006/relationships" xmlns:p="http://schemas.openxmlformats.org/presentationml/2006/main">
   <p:cSld>
     <p:bg>
       <p:bgPr>
@@ -6699,7 +7013,14 @@
         <p:cNvGrpSpPr/>
         <p:nvPr/>
       </p:nvGrpSpPr>
-      <p:grpSpPr/>
+      <p:grpSpPr>
+        <a:xfrm>
+          <a:off x="0" y="0"/>
+          <a:ext cx="0" cy="0"/>
+          <a:chOff x="0" y="0"/>
+          <a:chExt cx="0" cy="0"/>
+        </a:xfrm>
+      </p:grpSpPr>
       <p:sp>
         <p:nvSpPr>
           <p:cNvPr id="2" name="Rectangle 1"/>
@@ -6736,7 +7057,7 @@
           </a:fontRef>
         </p:style>
         <p:txBody>
-          <a:bodyPr rtlCol="0" anchor="ctr" wrap="square" lIns="457200" tIns="137160"/>
+          <a:bodyPr wrap="square" lIns="457200" tIns="137160" rtlCol="0" anchor="ctr"/>
           <a:lstStyle/>
           <a:p>
             <a:pPr algn="ctr">
@@ -6868,6 +7189,7 @@
           <a:lstStyle/>
           <a:p>
             <a:pPr algn="ctr"/>
+            <a:endParaRPr/>
           </a:p>
         </p:txBody>
       </p:sp>
@@ -6907,7 +7229,7 @@
           </a:fontRef>
         </p:style>
         <p:txBody>
-          <a:bodyPr rtlCol="0" anchor="ctr" lIns="182880" tIns="91440"/>
+          <a:bodyPr lIns="182880" tIns="91440" rtlCol="0" anchor="ctr"/>
           <a:lstStyle/>
           <a:p>
             <a:pPr algn="ctr">
@@ -7013,7 +7335,7 @@
 </file>
 
 <file path=ppt/slides/slide19.xml><?xml version="1.0" encoding="utf-8"?>
-<p:sld xmlns:a="http://schemas.openxmlformats.org/drawingml/2006/main" xmlns:p="http://schemas.openxmlformats.org/presentationml/2006/main" xmlns:r="http://schemas.openxmlformats.org/officeDocument/2006/relationships">
+<p:sld xmlns:a="http://schemas.openxmlformats.org/drawingml/2006/main" xmlns:r="http://schemas.openxmlformats.org/officeDocument/2006/relationships" xmlns:p="http://schemas.openxmlformats.org/presentationml/2006/main">
   <p:cSld>
     <p:bg>
       <p:bgPr>
@@ -7029,7 +7351,14 @@
         <p:cNvGrpSpPr/>
         <p:nvPr/>
       </p:nvGrpSpPr>
-      <p:grpSpPr/>
+      <p:grpSpPr>
+        <a:xfrm>
+          <a:off x="0" y="0"/>
+          <a:ext cx="0" cy="0"/>
+          <a:chOff x="0" y="0"/>
+          <a:chExt cx="0" cy="0"/>
+        </a:xfrm>
+      </p:grpSpPr>
       <p:sp>
         <p:nvSpPr>
           <p:cNvPr id="2" name="Rectangle 1"/>
@@ -7066,7 +7395,7 @@
           </a:fontRef>
         </p:style>
         <p:txBody>
-          <a:bodyPr rtlCol="0" anchor="ctr" wrap="square" lIns="457200" tIns="137160"/>
+          <a:bodyPr wrap="square" lIns="457200" tIns="137160" rtlCol="0" anchor="ctr"/>
           <a:lstStyle/>
           <a:p>
             <a:pPr algn="ctr">
@@ -7198,6 +7527,7 @@
           <a:lstStyle/>
           <a:p>
             <a:pPr algn="ctr"/>
+            <a:endParaRPr/>
           </a:p>
         </p:txBody>
       </p:sp>
@@ -7237,7 +7567,7 @@
           </a:fontRef>
         </p:style>
         <p:txBody>
-          <a:bodyPr rtlCol="0" anchor="ctr" lIns="182880" tIns="91440"/>
+          <a:bodyPr lIns="182880" tIns="91440" rtlCol="0" anchor="ctr"/>
           <a:lstStyle/>
           <a:p>
             <a:pPr algn="ctr">
@@ -7343,7 +7673,7 @@
 </file>
 
 <file path=ppt/slides/slide2.xml><?xml version="1.0" encoding="utf-8"?>
-<p:sld xmlns:a="http://schemas.openxmlformats.org/drawingml/2006/main" xmlns:p="http://schemas.openxmlformats.org/presentationml/2006/main" xmlns:r="http://schemas.openxmlformats.org/officeDocument/2006/relationships">
+<p:sld xmlns:a="http://schemas.openxmlformats.org/drawingml/2006/main" xmlns:r="http://schemas.openxmlformats.org/officeDocument/2006/relationships" xmlns:p="http://schemas.openxmlformats.org/presentationml/2006/main">
   <p:cSld>
     <p:bg>
       <p:bgPr>
@@ -7359,7 +7689,14 @@
         <p:cNvGrpSpPr/>
         <p:nvPr/>
       </p:nvGrpSpPr>
-      <p:grpSpPr/>
+      <p:grpSpPr>
+        <a:xfrm>
+          <a:off x="0" y="0"/>
+          <a:ext cx="0" cy="0"/>
+          <a:chOff x="0" y="0"/>
+          <a:chExt cx="0" cy="0"/>
+        </a:xfrm>
+      </p:grpSpPr>
       <p:sp>
         <p:nvSpPr>
           <p:cNvPr id="2" name="Rectangle 1"/>
@@ -7396,7 +7733,7 @@
           </a:fontRef>
         </p:style>
         <p:txBody>
-          <a:bodyPr rtlCol="0" anchor="ctr" wrap="square" lIns="457200" tIns="137160"/>
+          <a:bodyPr wrap="square" lIns="457200" tIns="137160" rtlCol="0" anchor="ctr"/>
           <a:lstStyle/>
           <a:p>
             <a:pPr algn="ctr">
@@ -7504,6 +7841,7 @@
           <a:lstStyle/>
           <a:p>
             <a:pPr algn="ctr"/>
+            <a:endParaRPr/>
           </a:p>
         </p:txBody>
       </p:sp>
@@ -7543,7 +7881,7 @@
           </a:fontRef>
         </p:style>
         <p:txBody>
-          <a:bodyPr rtlCol="0" anchor="ctr" lIns="182880" tIns="91440"/>
+          <a:bodyPr lIns="182880" tIns="91440" rtlCol="0" anchor="ctr"/>
           <a:lstStyle/>
           <a:p>
             <a:pPr algn="ctr">
@@ -7686,6 +8024,7 @@
           <a:lstStyle/>
           <a:p>
             <a:pPr algn="ctr"/>
+            <a:endParaRPr/>
           </a:p>
         </p:txBody>
       </p:sp>
@@ -7725,7 +8064,7 @@
           </a:fontRef>
         </p:style>
         <p:txBody>
-          <a:bodyPr rtlCol="0" anchor="ctr" lIns="182880" tIns="91440"/>
+          <a:bodyPr lIns="182880" tIns="91440" rtlCol="0" anchor="ctr"/>
           <a:lstStyle/>
           <a:p>
             <a:pPr algn="ctr">
@@ -7852,6 +8191,7 @@
           <a:lstStyle/>
           <a:p>
             <a:pPr algn="ctr"/>
+            <a:endParaRPr/>
           </a:p>
         </p:txBody>
       </p:sp>
@@ -7891,7 +8231,7 @@
           </a:fontRef>
         </p:style>
         <p:txBody>
-          <a:bodyPr rtlCol="0" anchor="ctr" lIns="182880" tIns="91440"/>
+          <a:bodyPr lIns="182880" tIns="91440" rtlCol="0" anchor="ctr"/>
           <a:lstStyle/>
           <a:p>
             <a:pPr algn="ctr">
@@ -8001,7 +8341,7 @@
 </file>
 
 <file path=ppt/slides/slide20.xml><?xml version="1.0" encoding="utf-8"?>
-<p:sld xmlns:a="http://schemas.openxmlformats.org/drawingml/2006/main" xmlns:p="http://schemas.openxmlformats.org/presentationml/2006/main" xmlns:r="http://schemas.openxmlformats.org/officeDocument/2006/relationships">
+<p:sld xmlns:a="http://schemas.openxmlformats.org/drawingml/2006/main" xmlns:r="http://schemas.openxmlformats.org/officeDocument/2006/relationships" xmlns:p="http://schemas.openxmlformats.org/presentationml/2006/main">
   <p:cSld>
     <p:bg>
       <p:bgPr>
@@ -8017,7 +8357,14 @@
         <p:cNvGrpSpPr/>
         <p:nvPr/>
       </p:nvGrpSpPr>
-      <p:grpSpPr/>
+      <p:grpSpPr>
+        <a:xfrm>
+          <a:off x="0" y="0"/>
+          <a:ext cx="0" cy="0"/>
+          <a:chOff x="0" y="0"/>
+          <a:chExt cx="0" cy="0"/>
+        </a:xfrm>
+      </p:grpSpPr>
       <p:sp>
         <p:nvSpPr>
           <p:cNvPr id="2" name="Rectangle 1"/>
@@ -8054,7 +8401,7 @@
           </a:fontRef>
         </p:style>
         <p:txBody>
-          <a:bodyPr rtlCol="0" anchor="ctr" wrap="square" lIns="457200" tIns="137160"/>
+          <a:bodyPr wrap="square" lIns="457200" tIns="137160" rtlCol="0" anchor="ctr"/>
           <a:lstStyle/>
           <a:p>
             <a:pPr algn="ctr">
@@ -8162,6 +8509,7 @@
           <a:lstStyle/>
           <a:p>
             <a:pPr algn="ctr"/>
+            <a:endParaRPr/>
           </a:p>
         </p:txBody>
       </p:sp>
@@ -8201,7 +8549,7 @@
           </a:fontRef>
         </p:style>
         <p:txBody>
-          <a:bodyPr rtlCol="0" anchor="ctr" lIns="182880" tIns="91440"/>
+          <a:bodyPr lIns="182880" tIns="91440" rtlCol="0" anchor="ctr"/>
           <a:lstStyle/>
           <a:p>
             <a:pPr algn="ctr">
@@ -8340,6 +8688,7 @@
           <a:lstStyle/>
           <a:p>
             <a:pPr algn="ctr"/>
+            <a:endParaRPr/>
           </a:p>
         </p:txBody>
       </p:sp>
@@ -8379,7 +8728,7 @@
           </a:fontRef>
         </p:style>
         <p:txBody>
-          <a:bodyPr rtlCol="0" anchor="ctr" lIns="182880" tIns="91440"/>
+          <a:bodyPr lIns="182880" tIns="91440" rtlCol="0" anchor="ctr"/>
           <a:lstStyle/>
           <a:p>
             <a:pPr algn="ctr">
@@ -8485,7 +8834,7 @@
 </file>
 
 <file path=ppt/slides/slide21.xml><?xml version="1.0" encoding="utf-8"?>
-<p:sld xmlns:a="http://schemas.openxmlformats.org/drawingml/2006/main" xmlns:p="http://schemas.openxmlformats.org/presentationml/2006/main" xmlns:r="http://schemas.openxmlformats.org/officeDocument/2006/relationships">
+<p:sld xmlns:a="http://schemas.openxmlformats.org/drawingml/2006/main" xmlns:r="http://schemas.openxmlformats.org/officeDocument/2006/relationships" xmlns:p="http://schemas.openxmlformats.org/presentationml/2006/main">
   <p:cSld>
     <p:bg>
       <p:bgPr>
@@ -8501,7 +8850,14 @@
         <p:cNvGrpSpPr/>
         <p:nvPr/>
       </p:nvGrpSpPr>
-      <p:grpSpPr/>
+      <p:grpSpPr>
+        <a:xfrm>
+          <a:off x="0" y="0"/>
+          <a:ext cx="0" cy="0"/>
+          <a:chOff x="0" y="0"/>
+          <a:chExt cx="0" cy="0"/>
+        </a:xfrm>
+      </p:grpSpPr>
       <p:sp>
         <p:nvSpPr>
           <p:cNvPr id="2" name="Rectangle 1"/>
@@ -8538,7 +8894,7 @@
           </a:fontRef>
         </p:style>
         <p:txBody>
-          <a:bodyPr rtlCol="0" anchor="ctr" wrap="square" lIns="457200" tIns="137160"/>
+          <a:bodyPr wrap="square" lIns="457200" tIns="137160" rtlCol="0" anchor="ctr"/>
           <a:lstStyle/>
           <a:p>
             <a:pPr algn="ctr">
@@ -8670,6 +9026,7 @@
           <a:lstStyle/>
           <a:p>
             <a:pPr algn="ctr"/>
+            <a:endParaRPr/>
           </a:p>
         </p:txBody>
       </p:sp>
@@ -8709,7 +9066,7 @@
           </a:fontRef>
         </p:style>
         <p:txBody>
-          <a:bodyPr rtlCol="0" anchor="ctr" lIns="182880" tIns="91440"/>
+          <a:bodyPr lIns="182880" tIns="91440" rtlCol="0" anchor="ctr"/>
           <a:lstStyle/>
           <a:p>
             <a:pPr algn="ctr">
@@ -8815,7 +9172,7 @@
 </file>
 
 <file path=ppt/slides/slide22.xml><?xml version="1.0" encoding="utf-8"?>
-<p:sld xmlns:a="http://schemas.openxmlformats.org/drawingml/2006/main" xmlns:p="http://schemas.openxmlformats.org/presentationml/2006/main" xmlns:r="http://schemas.openxmlformats.org/officeDocument/2006/relationships">
+<p:sld xmlns:a="http://schemas.openxmlformats.org/drawingml/2006/main" xmlns:r="http://schemas.openxmlformats.org/officeDocument/2006/relationships" xmlns:p="http://schemas.openxmlformats.org/presentationml/2006/main">
   <p:cSld>
     <p:bg>
       <p:bgPr>
@@ -8831,7 +9188,14 @@
         <p:cNvGrpSpPr/>
         <p:nvPr/>
       </p:nvGrpSpPr>
-      <p:grpSpPr/>
+      <p:grpSpPr>
+        <a:xfrm>
+          <a:off x="0" y="0"/>
+          <a:ext cx="0" cy="0"/>
+          <a:chOff x="0" y="0"/>
+          <a:chExt cx="0" cy="0"/>
+        </a:xfrm>
+      </p:grpSpPr>
       <p:sp>
         <p:nvSpPr>
           <p:cNvPr id="2" name="Rectangle 1"/>
@@ -8868,7 +9232,7 @@
           </a:fontRef>
         </p:style>
         <p:txBody>
-          <a:bodyPr rtlCol="0" anchor="ctr" wrap="square" lIns="457200" tIns="137160"/>
+          <a:bodyPr wrap="square" lIns="457200" tIns="137160" rtlCol="0" anchor="ctr"/>
           <a:lstStyle/>
           <a:p>
             <a:pPr algn="ctr">
@@ -9000,6 +9364,7 @@
           <a:lstStyle/>
           <a:p>
             <a:pPr algn="ctr"/>
+            <a:endParaRPr/>
           </a:p>
         </p:txBody>
       </p:sp>
@@ -9039,7 +9404,7 @@
           </a:fontRef>
         </p:style>
         <p:txBody>
-          <a:bodyPr rtlCol="0" anchor="ctr" lIns="182880" tIns="91440"/>
+          <a:bodyPr lIns="182880" tIns="91440" rtlCol="0" anchor="ctr"/>
           <a:lstStyle/>
           <a:p>
             <a:pPr algn="ctr">
@@ -9145,7 +9510,7 @@
 </file>
 
 <file path=ppt/slides/slide23.xml><?xml version="1.0" encoding="utf-8"?>
-<p:sld xmlns:a="http://schemas.openxmlformats.org/drawingml/2006/main" xmlns:p="http://schemas.openxmlformats.org/presentationml/2006/main" xmlns:r="http://schemas.openxmlformats.org/officeDocument/2006/relationships">
+<p:sld xmlns:a="http://schemas.openxmlformats.org/drawingml/2006/main" xmlns:r="http://schemas.openxmlformats.org/officeDocument/2006/relationships" xmlns:p="http://schemas.openxmlformats.org/presentationml/2006/main">
   <p:cSld>
     <p:bg>
       <p:bgPr>
@@ -9161,7 +9526,14 @@
         <p:cNvGrpSpPr/>
         <p:nvPr/>
       </p:nvGrpSpPr>
-      <p:grpSpPr/>
+      <p:grpSpPr>
+        <a:xfrm>
+          <a:off x="0" y="0"/>
+          <a:ext cx="0" cy="0"/>
+          <a:chOff x="0" y="0"/>
+          <a:chExt cx="0" cy="0"/>
+        </a:xfrm>
+      </p:grpSpPr>
       <p:sp>
         <p:nvSpPr>
           <p:cNvPr id="2" name="Rectangle 1"/>
@@ -9198,7 +9570,7 @@
           </a:fontRef>
         </p:style>
         <p:txBody>
-          <a:bodyPr rtlCol="0" anchor="ctr" wrap="square" lIns="457200" tIns="137160"/>
+          <a:bodyPr wrap="square" lIns="457200" tIns="137160" rtlCol="0" anchor="ctr"/>
           <a:lstStyle/>
           <a:p>
             <a:pPr algn="ctr">
@@ -9330,6 +9702,7 @@
           <a:lstStyle/>
           <a:p>
             <a:pPr algn="ctr"/>
+            <a:endParaRPr/>
           </a:p>
         </p:txBody>
       </p:sp>
@@ -9369,7 +9742,7 @@
           </a:fontRef>
         </p:style>
         <p:txBody>
-          <a:bodyPr rtlCol="0" anchor="ctr" lIns="182880" tIns="91440"/>
+          <a:bodyPr lIns="182880" tIns="91440" rtlCol="0" anchor="ctr"/>
           <a:lstStyle/>
           <a:p>
             <a:pPr algn="ctr">
@@ -9475,7 +9848,7 @@
 </file>
 
 <file path=ppt/slides/slide24.xml><?xml version="1.0" encoding="utf-8"?>
-<p:sld xmlns:a="http://schemas.openxmlformats.org/drawingml/2006/main" xmlns:p="http://schemas.openxmlformats.org/presentationml/2006/main" xmlns:r="http://schemas.openxmlformats.org/officeDocument/2006/relationships">
+<p:sld xmlns:a="http://schemas.openxmlformats.org/drawingml/2006/main" xmlns:r="http://schemas.openxmlformats.org/officeDocument/2006/relationships" xmlns:p="http://schemas.openxmlformats.org/presentationml/2006/main">
   <p:cSld>
     <p:bg>
       <p:bgPr>
@@ -9491,7 +9864,14 @@
         <p:cNvGrpSpPr/>
         <p:nvPr/>
       </p:nvGrpSpPr>
-      <p:grpSpPr/>
+      <p:grpSpPr>
+        <a:xfrm>
+          <a:off x="0" y="0"/>
+          <a:ext cx="0" cy="0"/>
+          <a:chOff x="0" y="0"/>
+          <a:chExt cx="0" cy="0"/>
+        </a:xfrm>
+      </p:grpSpPr>
       <p:sp>
         <p:nvSpPr>
           <p:cNvPr id="2" name="Rectangle 1"/>
@@ -9528,7 +9908,7 @@
           </a:fontRef>
         </p:style>
         <p:txBody>
-          <a:bodyPr rtlCol="0" anchor="ctr" wrap="square" lIns="457200" tIns="137160"/>
+          <a:bodyPr wrap="square" lIns="457200" tIns="137160" rtlCol="0" anchor="ctr"/>
           <a:lstStyle/>
           <a:p>
             <a:pPr algn="ctr">
@@ -9660,6 +10040,7 @@
           <a:lstStyle/>
           <a:p>
             <a:pPr algn="ctr"/>
+            <a:endParaRPr/>
           </a:p>
         </p:txBody>
       </p:sp>
@@ -9699,7 +10080,7 @@
           </a:fontRef>
         </p:style>
         <p:txBody>
-          <a:bodyPr rtlCol="0" anchor="ctr" lIns="182880" tIns="91440"/>
+          <a:bodyPr lIns="182880" tIns="91440" rtlCol="0" anchor="ctr"/>
           <a:lstStyle/>
           <a:p>
             <a:pPr algn="ctr">
@@ -9805,7 +10186,7 @@
 </file>
 
 <file path=ppt/slides/slide25.xml><?xml version="1.0" encoding="utf-8"?>
-<p:sld xmlns:a="http://schemas.openxmlformats.org/drawingml/2006/main" xmlns:p="http://schemas.openxmlformats.org/presentationml/2006/main" xmlns:r="http://schemas.openxmlformats.org/officeDocument/2006/relationships">
+<p:sld xmlns:a="http://schemas.openxmlformats.org/drawingml/2006/main" xmlns:r="http://schemas.openxmlformats.org/officeDocument/2006/relationships" xmlns:p="http://schemas.openxmlformats.org/presentationml/2006/main">
   <p:cSld>
     <p:bg>
       <p:bgPr>
@@ -9821,7 +10202,14 @@
         <p:cNvGrpSpPr/>
         <p:nvPr/>
       </p:nvGrpSpPr>
-      <p:grpSpPr/>
+      <p:grpSpPr>
+        <a:xfrm>
+          <a:off x="0" y="0"/>
+          <a:ext cx="0" cy="0"/>
+          <a:chOff x="0" y="0"/>
+          <a:chExt cx="0" cy="0"/>
+        </a:xfrm>
+      </p:grpSpPr>
       <p:sp>
         <p:nvSpPr>
           <p:cNvPr id="2" name="Rectangle 1"/>
@@ -9858,7 +10246,7 @@
           </a:fontRef>
         </p:style>
         <p:txBody>
-          <a:bodyPr rtlCol="0" anchor="ctr" wrap="square" lIns="457200" tIns="137160"/>
+          <a:bodyPr wrap="square" lIns="457200" tIns="137160" rtlCol="0" anchor="ctr"/>
           <a:lstStyle/>
           <a:p>
             <a:pPr algn="ctr">
@@ -9990,6 +10378,7 @@
           <a:lstStyle/>
           <a:p>
             <a:pPr algn="ctr"/>
+            <a:endParaRPr/>
           </a:p>
         </p:txBody>
       </p:sp>
@@ -10029,7 +10418,7 @@
           </a:fontRef>
         </p:style>
         <p:txBody>
-          <a:bodyPr rtlCol="0" anchor="ctr" lIns="182880" tIns="91440"/>
+          <a:bodyPr lIns="182880" tIns="91440" rtlCol="0" anchor="ctr"/>
           <a:lstStyle/>
           <a:p>
             <a:pPr algn="ctr">
@@ -10135,7 +10524,7 @@
 </file>
 
 <file path=ppt/slides/slide26.xml><?xml version="1.0" encoding="utf-8"?>
-<p:sld xmlns:a="http://schemas.openxmlformats.org/drawingml/2006/main" xmlns:p="http://schemas.openxmlformats.org/presentationml/2006/main" xmlns:r="http://schemas.openxmlformats.org/officeDocument/2006/relationships">
+<p:sld xmlns:a="http://schemas.openxmlformats.org/drawingml/2006/main" xmlns:r="http://schemas.openxmlformats.org/officeDocument/2006/relationships" xmlns:p="http://schemas.openxmlformats.org/presentationml/2006/main">
   <p:cSld>
     <p:bg>
       <p:bgPr>
@@ -10151,7 +10540,14 @@
         <p:cNvGrpSpPr/>
         <p:nvPr/>
       </p:nvGrpSpPr>
-      <p:grpSpPr/>
+      <p:grpSpPr>
+        <a:xfrm>
+          <a:off x="0" y="0"/>
+          <a:ext cx="0" cy="0"/>
+          <a:chOff x="0" y="0"/>
+          <a:chExt cx="0" cy="0"/>
+        </a:xfrm>
+      </p:grpSpPr>
       <p:sp>
         <p:nvSpPr>
           <p:cNvPr id="2" name="Rectangle 1"/>
@@ -10188,7 +10584,7 @@
           </a:fontRef>
         </p:style>
         <p:txBody>
-          <a:bodyPr rtlCol="0" anchor="ctr" wrap="square" lIns="457200" tIns="137160"/>
+          <a:bodyPr wrap="square" lIns="457200" tIns="137160" rtlCol="0" anchor="ctr"/>
           <a:lstStyle/>
           <a:p>
             <a:pPr algn="ctr">
@@ -10256,7 +10652,7 @@
       </p:sp>
       <p:pic>
         <p:nvPicPr>
-          <p:cNvPr id="4" name="Picture 3" descr="fig12_channel_benchmark.png"/>
+          <p:cNvPr id="4" name="Picture 3"/>
           <p:cNvPicPr>
             <a:picLocks noChangeAspect="1"/>
           </p:cNvPicPr>
@@ -10264,14 +10660,13 @@
         </p:nvPicPr>
         <p:blipFill>
           <a:blip r:embed="rId2"/>
-          <a:stretch>
-            <a:fillRect/>
-          </a:stretch>
+          <a:srcRect/>
+          <a:stretch/>
         </p:blipFill>
         <p:spPr>
           <a:xfrm>
-            <a:off x="548640" y="1463040"/>
-            <a:ext cx="5943600" cy="3268980"/>
+            <a:off x="752352" y="1463040"/>
+            <a:ext cx="5536175" cy="3268980"/>
           </a:xfrm>
           <a:prstGeom prst="rect">
             <a:avLst/>
@@ -10320,6 +10715,7 @@
           <a:lstStyle/>
           <a:p>
             <a:pPr algn="ctr"/>
+            <a:endParaRPr/>
           </a:p>
         </p:txBody>
       </p:sp>
@@ -10359,7 +10755,7 @@
           </a:fontRef>
         </p:style>
         <p:txBody>
-          <a:bodyPr rtlCol="0" anchor="ctr" lIns="182880" tIns="91440"/>
+          <a:bodyPr lIns="182880" tIns="91440" rtlCol="0" anchor="ctr"/>
           <a:lstStyle/>
           <a:p>
             <a:pPr algn="ctr">
@@ -10465,7 +10861,7 @@
 </file>
 
 <file path=ppt/slides/slide27.xml><?xml version="1.0" encoding="utf-8"?>
-<p:sld xmlns:a="http://schemas.openxmlformats.org/drawingml/2006/main" xmlns:p="http://schemas.openxmlformats.org/presentationml/2006/main" xmlns:r="http://schemas.openxmlformats.org/officeDocument/2006/relationships">
+<p:sld xmlns:a="http://schemas.openxmlformats.org/drawingml/2006/main" xmlns:r="http://schemas.openxmlformats.org/officeDocument/2006/relationships" xmlns:p="http://schemas.openxmlformats.org/presentationml/2006/main">
   <p:cSld>
     <p:bg>
       <p:bgPr>
@@ -10481,7 +10877,14 @@
         <p:cNvGrpSpPr/>
         <p:nvPr/>
       </p:nvGrpSpPr>
-      <p:grpSpPr/>
+      <p:grpSpPr>
+        <a:xfrm>
+          <a:off x="0" y="0"/>
+          <a:ext cx="0" cy="0"/>
+          <a:chOff x="0" y="0"/>
+          <a:chExt cx="0" cy="0"/>
+        </a:xfrm>
+      </p:grpSpPr>
       <p:sp>
         <p:nvSpPr>
           <p:cNvPr id="2" name="Rectangle 1"/>
@@ -10518,7 +10921,7 @@
           </a:fontRef>
         </p:style>
         <p:txBody>
-          <a:bodyPr rtlCol="0" anchor="ctr" wrap="square" lIns="457200" tIns="137160"/>
+          <a:bodyPr wrap="square" lIns="457200" tIns="137160" rtlCol="0" anchor="ctr"/>
           <a:lstStyle/>
           <a:p>
             <a:pPr algn="ctr">
@@ -10626,6 +11029,7 @@
           <a:lstStyle/>
           <a:p>
             <a:pPr algn="ctr"/>
+            <a:endParaRPr/>
           </a:p>
         </p:txBody>
       </p:sp>
@@ -10665,7 +11069,7 @@
           </a:fontRef>
         </p:style>
         <p:txBody>
-          <a:bodyPr rtlCol="0" anchor="ctr" lIns="182880" tIns="91440"/>
+          <a:bodyPr lIns="182880" tIns="91440" rtlCol="0" anchor="ctr"/>
           <a:lstStyle/>
           <a:p>
             <a:pPr algn="ctr">
@@ -10804,6 +11208,7 @@
           <a:lstStyle/>
           <a:p>
             <a:pPr algn="ctr"/>
+            <a:endParaRPr/>
           </a:p>
         </p:txBody>
       </p:sp>
@@ -10843,7 +11248,7 @@
           </a:fontRef>
         </p:style>
         <p:txBody>
-          <a:bodyPr rtlCol="0" anchor="ctr" lIns="182880" tIns="91440"/>
+          <a:bodyPr lIns="182880" tIns="91440" rtlCol="0" anchor="ctr"/>
           <a:lstStyle/>
           <a:p>
             <a:pPr algn="ctr">
@@ -10949,7 +11354,7 @@
 </file>
 
 <file path=ppt/slides/slide28.xml><?xml version="1.0" encoding="utf-8"?>
-<p:sld xmlns:a="http://schemas.openxmlformats.org/drawingml/2006/main" xmlns:p="http://schemas.openxmlformats.org/presentationml/2006/main" xmlns:r="http://schemas.openxmlformats.org/officeDocument/2006/relationships">
+<p:sld xmlns:a="http://schemas.openxmlformats.org/drawingml/2006/main" xmlns:r="http://schemas.openxmlformats.org/officeDocument/2006/relationships" xmlns:p="http://schemas.openxmlformats.org/presentationml/2006/main">
   <p:cSld>
     <p:bg>
       <p:bgPr>
@@ -10965,7 +11370,14 @@
         <p:cNvGrpSpPr/>
         <p:nvPr/>
       </p:nvGrpSpPr>
-      <p:grpSpPr/>
+      <p:grpSpPr>
+        <a:xfrm>
+          <a:off x="0" y="0"/>
+          <a:ext cx="0" cy="0"/>
+          <a:chOff x="0" y="0"/>
+          <a:chExt cx="0" cy="0"/>
+        </a:xfrm>
+      </p:grpSpPr>
       <p:sp>
         <p:nvSpPr>
           <p:cNvPr id="2" name="Rectangle 1"/>
@@ -11002,7 +11414,7 @@
           </a:fontRef>
         </p:style>
         <p:txBody>
-          <a:bodyPr rtlCol="0" anchor="ctr" wrap="square" lIns="457200" tIns="137160"/>
+          <a:bodyPr wrap="square" lIns="457200" tIns="137160" rtlCol="0" anchor="ctr"/>
           <a:lstStyle/>
           <a:p>
             <a:pPr algn="ctr">
@@ -11134,6 +11546,7 @@
           <a:lstStyle/>
           <a:p>
             <a:pPr algn="ctr"/>
+            <a:endParaRPr/>
           </a:p>
         </p:txBody>
       </p:sp>
@@ -11173,7 +11586,7 @@
           </a:fontRef>
         </p:style>
         <p:txBody>
-          <a:bodyPr rtlCol="0" anchor="ctr" lIns="182880" tIns="91440"/>
+          <a:bodyPr lIns="182880" tIns="91440" rtlCol="0" anchor="ctr"/>
           <a:lstStyle/>
           <a:p>
             <a:pPr algn="ctr">
@@ -11279,7 +11692,7 @@
 </file>
 
 <file path=ppt/slides/slide29.xml><?xml version="1.0" encoding="utf-8"?>
-<p:sld xmlns:a="http://schemas.openxmlformats.org/drawingml/2006/main" xmlns:p="http://schemas.openxmlformats.org/presentationml/2006/main" xmlns:r="http://schemas.openxmlformats.org/officeDocument/2006/relationships">
+<p:sld xmlns:a="http://schemas.openxmlformats.org/drawingml/2006/main" xmlns:r="http://schemas.openxmlformats.org/officeDocument/2006/relationships" xmlns:p="http://schemas.openxmlformats.org/presentationml/2006/main">
   <p:cSld>
     <p:bg>
       <p:bgPr>
@@ -11295,7 +11708,14 @@
         <p:cNvGrpSpPr/>
         <p:nvPr/>
       </p:nvGrpSpPr>
-      <p:grpSpPr/>
+      <p:grpSpPr>
+        <a:xfrm>
+          <a:off x="0" y="0"/>
+          <a:ext cx="0" cy="0"/>
+          <a:chOff x="0" y="0"/>
+          <a:chExt cx="0" cy="0"/>
+        </a:xfrm>
+      </p:grpSpPr>
       <p:sp>
         <p:nvSpPr>
           <p:cNvPr id="2" name="Rectangle 1"/>
@@ -11332,7 +11752,7 @@
           </a:fontRef>
         </p:style>
         <p:txBody>
-          <a:bodyPr rtlCol="0" anchor="ctr" wrap="square" lIns="457200" tIns="137160"/>
+          <a:bodyPr wrap="square" lIns="457200" tIns="137160" rtlCol="0" anchor="ctr"/>
           <a:lstStyle/>
           <a:p>
             <a:pPr algn="ctr">
@@ -11440,6 +11860,7 @@
           <a:lstStyle/>
           <a:p>
             <a:pPr algn="ctr"/>
+            <a:endParaRPr/>
           </a:p>
         </p:txBody>
       </p:sp>
@@ -11479,7 +11900,7 @@
           </a:fontRef>
         </p:style>
         <p:txBody>
-          <a:bodyPr rtlCol="0" anchor="ctr" lIns="182880" tIns="91440"/>
+          <a:bodyPr lIns="182880" tIns="91440" rtlCol="0" anchor="ctr"/>
           <a:lstStyle/>
           <a:p>
             <a:pPr algn="ctr">
@@ -11606,6 +12027,7 @@
           <a:lstStyle/>
           <a:p>
             <a:pPr algn="ctr"/>
+            <a:endParaRPr/>
           </a:p>
         </p:txBody>
       </p:sp>
@@ -11645,7 +12067,7 @@
           </a:fontRef>
         </p:style>
         <p:txBody>
-          <a:bodyPr rtlCol="0" anchor="ctr" lIns="182880" tIns="91440"/>
+          <a:bodyPr lIns="182880" tIns="91440" rtlCol="0" anchor="ctr"/>
           <a:lstStyle/>
           <a:p>
             <a:pPr algn="ctr">
@@ -11739,7 +12161,7 @@
 </file>
 
 <file path=ppt/slides/slide3.xml><?xml version="1.0" encoding="utf-8"?>
-<p:sld xmlns:a="http://schemas.openxmlformats.org/drawingml/2006/main" xmlns:p="http://schemas.openxmlformats.org/presentationml/2006/main" xmlns:r="http://schemas.openxmlformats.org/officeDocument/2006/relationships">
+<p:sld xmlns:a="http://schemas.openxmlformats.org/drawingml/2006/main" xmlns:r="http://schemas.openxmlformats.org/officeDocument/2006/relationships" xmlns:p="http://schemas.openxmlformats.org/presentationml/2006/main">
   <p:cSld>
     <p:bg>
       <p:bgPr>
@@ -11755,7 +12177,14 @@
         <p:cNvGrpSpPr/>
         <p:nvPr/>
       </p:nvGrpSpPr>
-      <p:grpSpPr/>
+      <p:grpSpPr>
+        <a:xfrm>
+          <a:off x="0" y="0"/>
+          <a:ext cx="0" cy="0"/>
+          <a:chOff x="0" y="0"/>
+          <a:chExt cx="0" cy="0"/>
+        </a:xfrm>
+      </p:grpSpPr>
       <p:sp>
         <p:nvSpPr>
           <p:cNvPr id="2" name="Rectangle 1"/>
@@ -11792,7 +12221,7 @@
           </a:fontRef>
         </p:style>
         <p:txBody>
-          <a:bodyPr rtlCol="0" anchor="ctr" wrap="square" lIns="457200" tIns="137160"/>
+          <a:bodyPr wrap="square" lIns="457200" tIns="137160" rtlCol="0" anchor="ctr"/>
           <a:lstStyle/>
           <a:p>
             <a:pPr algn="ctr">
@@ -11900,6 +12329,7 @@
           <a:lstStyle/>
           <a:p>
             <a:pPr algn="ctr"/>
+            <a:endParaRPr/>
           </a:p>
         </p:txBody>
       </p:sp>
@@ -11939,7 +12369,7 @@
           </a:fontRef>
         </p:style>
         <p:txBody>
-          <a:bodyPr rtlCol="0" anchor="ctr" lIns="182880" tIns="91440"/>
+          <a:bodyPr lIns="182880" tIns="91440" rtlCol="0" anchor="ctr"/>
           <a:lstStyle/>
           <a:p>
             <a:pPr algn="ctr">
@@ -12082,6 +12512,7 @@
           <a:lstStyle/>
           <a:p>
             <a:pPr algn="ctr"/>
+            <a:endParaRPr/>
           </a:p>
         </p:txBody>
       </p:sp>
@@ -12121,7 +12552,7 @@
           </a:fontRef>
         </p:style>
         <p:txBody>
-          <a:bodyPr rtlCol="0" anchor="ctr" lIns="182880" tIns="91440"/>
+          <a:bodyPr lIns="182880" tIns="91440" rtlCol="0" anchor="ctr"/>
           <a:lstStyle/>
           <a:p>
             <a:pPr algn="ctr">
@@ -12231,7 +12662,7 @@
 </file>
 
 <file path=ppt/slides/slide30.xml><?xml version="1.0" encoding="utf-8"?>
-<p:sld xmlns:a="http://schemas.openxmlformats.org/drawingml/2006/main" xmlns:p="http://schemas.openxmlformats.org/presentationml/2006/main" xmlns:r="http://schemas.openxmlformats.org/officeDocument/2006/relationships">
+<p:sld xmlns:a="http://schemas.openxmlformats.org/drawingml/2006/main" xmlns:r="http://schemas.openxmlformats.org/officeDocument/2006/relationships" xmlns:p="http://schemas.openxmlformats.org/presentationml/2006/main">
   <p:cSld>
     <p:bg>
       <p:bgPr>
@@ -12247,7 +12678,14 @@
         <p:cNvGrpSpPr/>
         <p:nvPr/>
       </p:nvGrpSpPr>
-      <p:grpSpPr/>
+      <p:grpSpPr>
+        <a:xfrm>
+          <a:off x="0" y="0"/>
+          <a:ext cx="0" cy="0"/>
+          <a:chOff x="0" y="0"/>
+          <a:chExt cx="0" cy="0"/>
+        </a:xfrm>
+      </p:grpSpPr>
       <p:sp>
         <p:nvSpPr>
           <p:cNvPr id="2" name="Rectangle 1"/>
@@ -12284,7 +12722,7 @@
           </a:fontRef>
         </p:style>
         <p:txBody>
-          <a:bodyPr rtlCol="0" anchor="ctr" wrap="square" lIns="457200" tIns="137160"/>
+          <a:bodyPr wrap="square" lIns="457200" tIns="137160" rtlCol="0" anchor="ctr"/>
           <a:lstStyle/>
           <a:p>
             <a:pPr algn="ctr">
@@ -12392,6 +12830,7 @@
           <a:lstStyle/>
           <a:p>
             <a:pPr algn="ctr"/>
+            <a:endParaRPr/>
           </a:p>
         </p:txBody>
       </p:sp>
@@ -12431,7 +12870,7 @@
           </a:fontRef>
         </p:style>
         <p:txBody>
-          <a:bodyPr rtlCol="0" anchor="ctr" lIns="182880" tIns="91440"/>
+          <a:bodyPr lIns="182880" tIns="91440" rtlCol="0" anchor="ctr"/>
           <a:lstStyle/>
           <a:p>
             <a:pPr algn="ctr">
@@ -12550,6 +12989,7 @@
           <a:lstStyle/>
           <a:p>
             <a:pPr algn="ctr"/>
+            <a:endParaRPr/>
           </a:p>
         </p:txBody>
       </p:sp>
@@ -12589,7 +13029,7 @@
           </a:fontRef>
         </p:style>
         <p:txBody>
-          <a:bodyPr rtlCol="0" anchor="ctr" lIns="182880" tIns="91440"/>
+          <a:bodyPr lIns="182880" tIns="91440" rtlCol="0" anchor="ctr"/>
           <a:lstStyle/>
           <a:p>
             <a:pPr algn="ctr">
@@ -12716,6 +13156,7 @@
           <a:lstStyle/>
           <a:p>
             <a:pPr algn="ctr"/>
+            <a:endParaRPr/>
           </a:p>
         </p:txBody>
       </p:sp>
@@ -12755,7 +13196,7 @@
           </a:fontRef>
         </p:style>
         <p:txBody>
-          <a:bodyPr rtlCol="0" anchor="ctr" lIns="182880" tIns="91440"/>
+          <a:bodyPr lIns="182880" tIns="91440" rtlCol="0" anchor="ctr"/>
           <a:lstStyle/>
           <a:p>
             <a:pPr algn="ctr">
@@ -12841,7 +13282,7 @@
 </file>
 
 <file path=ppt/slides/slide31.xml><?xml version="1.0" encoding="utf-8"?>
-<p:sld xmlns:a="http://schemas.openxmlformats.org/drawingml/2006/main" xmlns:p="http://schemas.openxmlformats.org/presentationml/2006/main" xmlns:r="http://schemas.openxmlformats.org/officeDocument/2006/relationships">
+<p:sld xmlns:a="http://schemas.openxmlformats.org/drawingml/2006/main" xmlns:r="http://schemas.openxmlformats.org/officeDocument/2006/relationships" xmlns:p="http://schemas.openxmlformats.org/presentationml/2006/main">
   <p:cSld>
     <p:bg>
       <p:bgPr>
@@ -12857,7 +13298,14 @@
         <p:cNvGrpSpPr/>
         <p:nvPr/>
       </p:nvGrpSpPr>
-      <p:grpSpPr/>
+      <p:grpSpPr>
+        <a:xfrm>
+          <a:off x="0" y="0"/>
+          <a:ext cx="0" cy="0"/>
+          <a:chOff x="0" y="0"/>
+          <a:chExt cx="0" cy="0"/>
+        </a:xfrm>
+      </p:grpSpPr>
       <p:sp>
         <p:nvSpPr>
           <p:cNvPr id="2" name="Rectangle 1"/>
@@ -12894,7 +13342,7 @@
           </a:fontRef>
         </p:style>
         <p:txBody>
-          <a:bodyPr rtlCol="0" anchor="ctr" wrap="square" lIns="457200" tIns="137160"/>
+          <a:bodyPr wrap="square" lIns="457200" tIns="137160" rtlCol="0" anchor="ctr"/>
           <a:lstStyle/>
           <a:p>
             <a:pPr algn="ctr">
@@ -12993,7 +13441,7 @@
 </file>
 
 <file path=ppt/slides/slide32.xml><?xml version="1.0" encoding="utf-8"?>
-<p:sld xmlns:a="http://schemas.openxmlformats.org/drawingml/2006/main" xmlns:p="http://schemas.openxmlformats.org/presentationml/2006/main" xmlns:r="http://schemas.openxmlformats.org/officeDocument/2006/relationships">
+<p:sld xmlns:a="http://schemas.openxmlformats.org/drawingml/2006/main" xmlns:r="http://schemas.openxmlformats.org/officeDocument/2006/relationships" xmlns:p="http://schemas.openxmlformats.org/presentationml/2006/main">
   <p:cSld>
     <p:bg>
       <p:bgPr>
@@ -13009,7 +13457,14 @@
         <p:cNvGrpSpPr/>
         <p:nvPr/>
       </p:nvGrpSpPr>
-      <p:grpSpPr/>
+      <p:grpSpPr>
+        <a:xfrm>
+          <a:off x="0" y="0"/>
+          <a:ext cx="0" cy="0"/>
+          <a:chOff x="0" y="0"/>
+          <a:chExt cx="0" cy="0"/>
+        </a:xfrm>
+      </p:grpSpPr>
       <p:sp>
         <p:nvSpPr>
           <p:cNvPr id="2" name="Rectangle 1"/>
@@ -13046,7 +13501,7 @@
           </a:fontRef>
         </p:style>
         <p:txBody>
-          <a:bodyPr rtlCol="0" anchor="ctr" wrap="square" lIns="457200" tIns="137160"/>
+          <a:bodyPr wrap="square" lIns="457200" tIns="137160" rtlCol="0" anchor="ctr"/>
           <a:lstStyle/>
           <a:p>
             <a:pPr algn="ctr">
@@ -13154,6 +13609,7 @@
           <a:lstStyle/>
           <a:p>
             <a:pPr algn="ctr"/>
+            <a:endParaRPr/>
           </a:p>
         </p:txBody>
       </p:sp>
@@ -13193,7 +13649,7 @@
           </a:fontRef>
         </p:style>
         <p:txBody>
-          <a:bodyPr rtlCol="0" anchor="ctr" lIns="182880" tIns="91440"/>
+          <a:bodyPr lIns="182880" tIns="91440" rtlCol="0" anchor="ctr"/>
           <a:lstStyle/>
           <a:p>
             <a:pPr algn="ctr">
@@ -13312,6 +13768,7 @@
           <a:lstStyle/>
           <a:p>
             <a:pPr algn="ctr"/>
+            <a:endParaRPr/>
           </a:p>
         </p:txBody>
       </p:sp>
@@ -13351,7 +13808,7 @@
           </a:fontRef>
         </p:style>
         <p:txBody>
-          <a:bodyPr rtlCol="0" anchor="ctr" lIns="182880" tIns="91440"/>
+          <a:bodyPr lIns="182880" tIns="91440" rtlCol="0" anchor="ctr"/>
           <a:lstStyle/>
           <a:p>
             <a:pPr algn="ctr">
@@ -13457,7 +13914,7 @@
 </file>
 
 <file path=ppt/slides/slide33.xml><?xml version="1.0" encoding="utf-8"?>
-<p:sld xmlns:a="http://schemas.openxmlformats.org/drawingml/2006/main" xmlns:p="http://schemas.openxmlformats.org/presentationml/2006/main" xmlns:r="http://schemas.openxmlformats.org/officeDocument/2006/relationships">
+<p:sld xmlns:a="http://schemas.openxmlformats.org/drawingml/2006/main" xmlns:r="http://schemas.openxmlformats.org/officeDocument/2006/relationships" xmlns:p="http://schemas.openxmlformats.org/presentationml/2006/main">
   <p:cSld>
     <p:bg>
       <p:bgPr>
@@ -13473,7 +13930,14 @@
         <p:cNvGrpSpPr/>
         <p:nvPr/>
       </p:nvGrpSpPr>
-      <p:grpSpPr/>
+      <p:grpSpPr>
+        <a:xfrm>
+          <a:off x="0" y="0"/>
+          <a:ext cx="0" cy="0"/>
+          <a:chOff x="0" y="0"/>
+          <a:chExt cx="0" cy="0"/>
+        </a:xfrm>
+      </p:grpSpPr>
       <p:sp>
         <p:nvSpPr>
           <p:cNvPr id="2" name="Rectangle 1"/>
@@ -13510,7 +13974,7 @@
           </a:fontRef>
         </p:style>
         <p:txBody>
-          <a:bodyPr rtlCol="0" anchor="ctr" wrap="square" lIns="457200" tIns="137160"/>
+          <a:bodyPr wrap="square" lIns="457200" tIns="137160" rtlCol="0" anchor="ctr"/>
           <a:lstStyle/>
           <a:p>
             <a:pPr algn="ctr">
@@ -13618,6 +14082,7 @@
           <a:lstStyle/>
           <a:p>
             <a:pPr algn="ctr"/>
+            <a:endParaRPr/>
           </a:p>
         </p:txBody>
       </p:sp>
@@ -13657,7 +14122,7 @@
           </a:fontRef>
         </p:style>
         <p:txBody>
-          <a:bodyPr rtlCol="0" anchor="ctr" lIns="182880" tIns="91440"/>
+          <a:bodyPr lIns="182880" tIns="91440" rtlCol="0" anchor="ctr"/>
           <a:lstStyle/>
           <a:p>
             <a:pPr algn="ctr">
@@ -13776,6 +14241,7 @@
           <a:lstStyle/>
           <a:p>
             <a:pPr algn="ctr"/>
+            <a:endParaRPr/>
           </a:p>
         </p:txBody>
       </p:sp>
@@ -13815,7 +14281,7 @@
           </a:fontRef>
         </p:style>
         <p:txBody>
-          <a:bodyPr rtlCol="0" anchor="ctr" lIns="182880" tIns="91440"/>
+          <a:bodyPr lIns="182880" tIns="91440" rtlCol="0" anchor="ctr"/>
           <a:lstStyle/>
           <a:p>
             <a:pPr algn="ctr">
@@ -13901,7 +14367,7 @@
 </file>
 
 <file path=ppt/slides/slide34.xml><?xml version="1.0" encoding="utf-8"?>
-<p:sld xmlns:a="http://schemas.openxmlformats.org/drawingml/2006/main" xmlns:p="http://schemas.openxmlformats.org/presentationml/2006/main" xmlns:r="http://schemas.openxmlformats.org/officeDocument/2006/relationships">
+<p:sld xmlns:a="http://schemas.openxmlformats.org/drawingml/2006/main" xmlns:r="http://schemas.openxmlformats.org/officeDocument/2006/relationships" xmlns:p="http://schemas.openxmlformats.org/presentationml/2006/main">
   <p:cSld>
     <p:bg>
       <p:bgPr>
@@ -13917,7 +14383,14 @@
         <p:cNvGrpSpPr/>
         <p:nvPr/>
       </p:nvGrpSpPr>
-      <p:grpSpPr/>
+      <p:grpSpPr>
+        <a:xfrm>
+          <a:off x="0" y="0"/>
+          <a:ext cx="0" cy="0"/>
+          <a:chOff x="0" y="0"/>
+          <a:chExt cx="0" cy="0"/>
+        </a:xfrm>
+      </p:grpSpPr>
       <p:sp>
         <p:nvSpPr>
           <p:cNvPr id="2" name="Rectangle 1"/>
@@ -13954,7 +14427,7 @@
           </a:fontRef>
         </p:style>
         <p:txBody>
-          <a:bodyPr rtlCol="0" anchor="ctr" wrap="square" lIns="457200" tIns="137160"/>
+          <a:bodyPr wrap="square" lIns="457200" tIns="137160" rtlCol="0" anchor="ctr"/>
           <a:lstStyle/>
           <a:p>
             <a:pPr algn="ctr">
@@ -14062,6 +14535,7 @@
           <a:lstStyle/>
           <a:p>
             <a:pPr algn="ctr"/>
+            <a:endParaRPr/>
           </a:p>
         </p:txBody>
       </p:sp>
@@ -14101,7 +14575,7 @@
           </a:fontRef>
         </p:style>
         <p:txBody>
-          <a:bodyPr rtlCol="0" anchor="ctr" lIns="182880" tIns="91440"/>
+          <a:bodyPr lIns="182880" tIns="91440" rtlCol="0" anchor="ctr"/>
           <a:lstStyle/>
           <a:p>
             <a:pPr algn="ctr">
@@ -14240,6 +14714,7 @@
           <a:lstStyle/>
           <a:p>
             <a:pPr algn="ctr"/>
+            <a:endParaRPr/>
           </a:p>
         </p:txBody>
       </p:sp>
@@ -14279,7 +14754,7 @@
           </a:fontRef>
         </p:style>
         <p:txBody>
-          <a:bodyPr rtlCol="0" anchor="ctr" lIns="182880" tIns="91440"/>
+          <a:bodyPr lIns="182880" tIns="91440" rtlCol="0" anchor="ctr"/>
           <a:lstStyle/>
           <a:p>
             <a:pPr algn="ctr">
@@ -14365,7 +14840,7 @@
 </file>
 
 <file path=ppt/slides/slide35.xml><?xml version="1.0" encoding="utf-8"?>
-<p:sld xmlns:a="http://schemas.openxmlformats.org/drawingml/2006/main" xmlns:p="http://schemas.openxmlformats.org/presentationml/2006/main" xmlns:r="http://schemas.openxmlformats.org/officeDocument/2006/relationships">
+<p:sld xmlns:a="http://schemas.openxmlformats.org/drawingml/2006/main" xmlns:r="http://schemas.openxmlformats.org/officeDocument/2006/relationships" xmlns:p="http://schemas.openxmlformats.org/presentationml/2006/main">
   <p:cSld>
     <p:bg>
       <p:bgPr>
@@ -14381,7 +14856,14 @@
         <p:cNvGrpSpPr/>
         <p:nvPr/>
       </p:nvGrpSpPr>
-      <p:grpSpPr/>
+      <p:grpSpPr>
+        <a:xfrm>
+          <a:off x="0" y="0"/>
+          <a:ext cx="0" cy="0"/>
+          <a:chOff x="0" y="0"/>
+          <a:chExt cx="0" cy="0"/>
+        </a:xfrm>
+      </p:grpSpPr>
       <p:sp>
         <p:nvSpPr>
           <p:cNvPr id="2" name="Rectangle 1"/>
@@ -14418,7 +14900,7 @@
           </a:fontRef>
         </p:style>
         <p:txBody>
-          <a:bodyPr rtlCol="0" anchor="ctr" wrap="square" lIns="457200" tIns="137160"/>
+          <a:bodyPr wrap="square" lIns="457200" tIns="137160" rtlCol="0" anchor="ctr"/>
           <a:lstStyle/>
           <a:p>
             <a:pPr algn="ctr">
@@ -14526,6 +15008,7 @@
           <a:lstStyle/>
           <a:p>
             <a:pPr algn="ctr"/>
+            <a:endParaRPr/>
           </a:p>
         </p:txBody>
       </p:sp>
@@ -14565,7 +15048,7 @@
           </a:fontRef>
         </p:style>
         <p:txBody>
-          <a:bodyPr rtlCol="0" anchor="ctr" lIns="182880" tIns="91440"/>
+          <a:bodyPr lIns="182880" tIns="91440" rtlCol="0" anchor="ctr"/>
           <a:lstStyle/>
           <a:p>
             <a:pPr algn="ctr">
@@ -14692,6 +15175,7 @@
           <a:lstStyle/>
           <a:p>
             <a:pPr algn="ctr"/>
+            <a:endParaRPr/>
           </a:p>
         </p:txBody>
       </p:sp>
@@ -14731,7 +15215,7 @@
           </a:fontRef>
         </p:style>
         <p:txBody>
-          <a:bodyPr rtlCol="0" anchor="ctr" lIns="182880" tIns="91440"/>
+          <a:bodyPr lIns="182880" tIns="91440" rtlCol="0" anchor="ctr"/>
           <a:lstStyle/>
           <a:p>
             <a:pPr algn="ctr">
@@ -14858,6 +15342,7 @@
           <a:lstStyle/>
           <a:p>
             <a:pPr algn="ctr"/>
+            <a:endParaRPr/>
           </a:p>
         </p:txBody>
       </p:sp>
@@ -14897,7 +15382,7 @@
           </a:fontRef>
         </p:style>
         <p:txBody>
-          <a:bodyPr rtlCol="0" anchor="ctr" lIns="182880" tIns="91440"/>
+          <a:bodyPr lIns="182880" tIns="91440" rtlCol="0" anchor="ctr"/>
           <a:lstStyle/>
           <a:p>
             <a:pPr algn="ctr">
@@ -14991,7 +15476,7 @@
 </file>
 
 <file path=ppt/slides/slide36.xml><?xml version="1.0" encoding="utf-8"?>
-<p:sld xmlns:a="http://schemas.openxmlformats.org/drawingml/2006/main" xmlns:p="http://schemas.openxmlformats.org/presentationml/2006/main" xmlns:r="http://schemas.openxmlformats.org/officeDocument/2006/relationships">
+<p:sld xmlns:a="http://schemas.openxmlformats.org/drawingml/2006/main" xmlns:r="http://schemas.openxmlformats.org/officeDocument/2006/relationships" xmlns:p="http://schemas.openxmlformats.org/presentationml/2006/main">
   <p:cSld>
     <p:bg>
       <p:bgPr>
@@ -15007,7 +15492,14 @@
         <p:cNvGrpSpPr/>
         <p:nvPr/>
       </p:nvGrpSpPr>
-      <p:grpSpPr/>
+      <p:grpSpPr>
+        <a:xfrm>
+          <a:off x="0" y="0"/>
+          <a:ext cx="0" cy="0"/>
+          <a:chOff x="0" y="0"/>
+          <a:chExt cx="0" cy="0"/>
+        </a:xfrm>
+      </p:grpSpPr>
       <p:sp>
         <p:nvSpPr>
           <p:cNvPr id="2" name="Rounded Rectangle 1"/>
@@ -15044,7 +15536,7 @@
           </a:fontRef>
         </p:style>
         <p:txBody>
-          <a:bodyPr rtlCol="0" anchor="ctr" wrap="square" lIns="731520" tIns="548640"/>
+          <a:bodyPr wrap="square" lIns="731520" tIns="548640" rtlCol="0" anchor="ctr"/>
           <a:lstStyle/>
           <a:p>
             <a:pPr algn="ctr">
@@ -15110,7 +15602,7 @@
 </file>
 
 <file path=ppt/slides/slide4.xml><?xml version="1.0" encoding="utf-8"?>
-<p:sld xmlns:a="http://schemas.openxmlformats.org/drawingml/2006/main" xmlns:p="http://schemas.openxmlformats.org/presentationml/2006/main" xmlns:r="http://schemas.openxmlformats.org/officeDocument/2006/relationships">
+<p:sld xmlns:a="http://schemas.openxmlformats.org/drawingml/2006/main" xmlns:r="http://schemas.openxmlformats.org/officeDocument/2006/relationships" xmlns:p="http://schemas.openxmlformats.org/presentationml/2006/main">
   <p:cSld>
     <p:bg>
       <p:bgPr>
@@ -15126,7 +15618,14 @@
         <p:cNvGrpSpPr/>
         <p:nvPr/>
       </p:nvGrpSpPr>
-      <p:grpSpPr/>
+      <p:grpSpPr>
+        <a:xfrm>
+          <a:off x="0" y="0"/>
+          <a:ext cx="0" cy="0"/>
+          <a:chOff x="0" y="0"/>
+          <a:chExt cx="0" cy="0"/>
+        </a:xfrm>
+      </p:grpSpPr>
       <p:sp>
         <p:nvSpPr>
           <p:cNvPr id="2" name="Rectangle 1"/>
@@ -15163,7 +15662,7 @@
           </a:fontRef>
         </p:style>
         <p:txBody>
-          <a:bodyPr rtlCol="0" anchor="ctr" wrap="square" lIns="457200" tIns="137160"/>
+          <a:bodyPr wrap="square" lIns="457200" tIns="137160" rtlCol="0" anchor="ctr"/>
           <a:lstStyle/>
           <a:p>
             <a:pPr algn="ctr">
@@ -15271,6 +15770,7 @@
           <a:lstStyle/>
           <a:p>
             <a:pPr algn="ctr"/>
+            <a:endParaRPr/>
           </a:p>
         </p:txBody>
       </p:sp>
@@ -15310,7 +15810,7 @@
           </a:fontRef>
         </p:style>
         <p:txBody>
-          <a:bodyPr rtlCol="0" anchor="ctr" lIns="182880" tIns="91440"/>
+          <a:bodyPr lIns="182880" tIns="91440" rtlCol="0" anchor="ctr"/>
           <a:lstStyle/>
           <a:p>
             <a:pPr algn="ctr">
@@ -15469,6 +15969,7 @@
           <a:lstStyle/>
           <a:p>
             <a:pPr algn="ctr"/>
+            <a:endParaRPr/>
           </a:p>
         </p:txBody>
       </p:sp>
@@ -15508,7 +16009,7 @@
           </a:fontRef>
         </p:style>
         <p:txBody>
-          <a:bodyPr rtlCol="0" anchor="ctr" lIns="182880" tIns="91440"/>
+          <a:bodyPr lIns="182880" tIns="91440" rtlCol="0" anchor="ctr"/>
           <a:lstStyle/>
           <a:p>
             <a:pPr algn="ctr">
@@ -15651,6 +16152,7 @@
           <a:lstStyle/>
           <a:p>
             <a:pPr algn="ctr"/>
+            <a:endParaRPr/>
           </a:p>
         </p:txBody>
       </p:sp>
@@ -15690,7 +16192,7 @@
           </a:fontRef>
         </p:style>
         <p:txBody>
-          <a:bodyPr rtlCol="0" anchor="ctr" lIns="182880" tIns="91440"/>
+          <a:bodyPr lIns="182880" tIns="91440" rtlCol="0" anchor="ctr"/>
           <a:lstStyle/>
           <a:p>
             <a:pPr algn="ctr">
@@ -15800,7 +16302,7 @@
 </file>
 
 <file path=ppt/slides/slide5.xml><?xml version="1.0" encoding="utf-8"?>
-<p:sld xmlns:a="http://schemas.openxmlformats.org/drawingml/2006/main" xmlns:p="http://schemas.openxmlformats.org/presentationml/2006/main" xmlns:r="http://schemas.openxmlformats.org/officeDocument/2006/relationships">
+<p:sld xmlns:a="http://schemas.openxmlformats.org/drawingml/2006/main" xmlns:r="http://schemas.openxmlformats.org/officeDocument/2006/relationships" xmlns:p="http://schemas.openxmlformats.org/presentationml/2006/main">
   <p:cSld>
     <p:bg>
       <p:bgPr>
@@ -15816,7 +16318,14 @@
         <p:cNvGrpSpPr/>
         <p:nvPr/>
       </p:nvGrpSpPr>
-      <p:grpSpPr/>
+      <p:grpSpPr>
+        <a:xfrm>
+          <a:off x="0" y="0"/>
+          <a:ext cx="0" cy="0"/>
+          <a:chOff x="0" y="0"/>
+          <a:chExt cx="0" cy="0"/>
+        </a:xfrm>
+      </p:grpSpPr>
       <p:sp>
         <p:nvSpPr>
           <p:cNvPr id="2" name="Rectangle 1"/>
@@ -15853,7 +16362,7 @@
           </a:fontRef>
         </p:style>
         <p:txBody>
-          <a:bodyPr rtlCol="0" anchor="ctr" wrap="square" lIns="457200" tIns="137160"/>
+          <a:bodyPr wrap="square" lIns="457200" tIns="137160" rtlCol="0" anchor="ctr"/>
           <a:lstStyle/>
           <a:p>
             <a:pPr algn="ctr">
@@ -15961,6 +16470,7 @@
           <a:lstStyle/>
           <a:p>
             <a:pPr algn="ctr"/>
+            <a:endParaRPr/>
           </a:p>
         </p:txBody>
       </p:sp>
@@ -16000,7 +16510,7 @@
           </a:fontRef>
         </p:style>
         <p:txBody>
-          <a:bodyPr rtlCol="0" anchor="ctr" lIns="182880" tIns="91440"/>
+          <a:bodyPr lIns="182880" tIns="91440" rtlCol="0" anchor="ctr"/>
           <a:lstStyle/>
           <a:p>
             <a:pPr algn="ctr">
@@ -16127,6 +16637,7 @@
           <a:lstStyle/>
           <a:p>
             <a:pPr algn="ctr"/>
+            <a:endParaRPr/>
           </a:p>
         </p:txBody>
       </p:sp>
@@ -16166,7 +16677,7 @@
           </a:fontRef>
         </p:style>
         <p:txBody>
-          <a:bodyPr rtlCol="0" anchor="ctr" lIns="182880" tIns="91440"/>
+          <a:bodyPr lIns="182880" tIns="91440" rtlCol="0" anchor="ctr"/>
           <a:lstStyle/>
           <a:p>
             <a:pPr algn="ctr">
@@ -16293,6 +16804,7 @@
           <a:lstStyle/>
           <a:p>
             <a:pPr algn="ctr"/>
+            <a:endParaRPr/>
           </a:p>
         </p:txBody>
       </p:sp>
@@ -16332,7 +16844,7 @@
           </a:fontRef>
         </p:style>
         <p:txBody>
-          <a:bodyPr rtlCol="0" anchor="ctr" lIns="182880" tIns="91440"/>
+          <a:bodyPr lIns="182880" tIns="91440" rtlCol="0" anchor="ctr"/>
           <a:lstStyle/>
           <a:p>
             <a:pPr algn="ctr">
@@ -16426,7 +16938,7 @@
 </file>
 
 <file path=ppt/slides/slide6.xml><?xml version="1.0" encoding="utf-8"?>
-<p:sld xmlns:a="http://schemas.openxmlformats.org/drawingml/2006/main" xmlns:p="http://schemas.openxmlformats.org/presentationml/2006/main" xmlns:r="http://schemas.openxmlformats.org/officeDocument/2006/relationships">
+<p:sld xmlns:a="http://schemas.openxmlformats.org/drawingml/2006/main" xmlns:r="http://schemas.openxmlformats.org/officeDocument/2006/relationships" xmlns:p="http://schemas.openxmlformats.org/presentationml/2006/main">
   <p:cSld>
     <p:bg>
       <p:bgPr>
@@ -16442,7 +16954,14 @@
         <p:cNvGrpSpPr/>
         <p:nvPr/>
       </p:nvGrpSpPr>
-      <p:grpSpPr/>
+      <p:grpSpPr>
+        <a:xfrm>
+          <a:off x="0" y="0"/>
+          <a:ext cx="0" cy="0"/>
+          <a:chOff x="0" y="0"/>
+          <a:chExt cx="0" cy="0"/>
+        </a:xfrm>
+      </p:grpSpPr>
       <p:sp>
         <p:nvSpPr>
           <p:cNvPr id="2" name="Rectangle 1"/>
@@ -16479,7 +16998,7 @@
           </a:fontRef>
         </p:style>
         <p:txBody>
-          <a:bodyPr rtlCol="0" anchor="ctr" wrap="square" lIns="457200" tIns="137160"/>
+          <a:bodyPr wrap="square" lIns="457200" tIns="137160" rtlCol="0" anchor="ctr"/>
           <a:lstStyle/>
           <a:p>
             <a:pPr algn="ctr">
@@ -16611,6 +17130,7 @@
           <a:lstStyle/>
           <a:p>
             <a:pPr algn="ctr"/>
+            <a:endParaRPr/>
           </a:p>
         </p:txBody>
       </p:sp>
@@ -16650,7 +17170,7 @@
           </a:fontRef>
         </p:style>
         <p:txBody>
-          <a:bodyPr rtlCol="0" anchor="ctr" lIns="182880" tIns="91440"/>
+          <a:bodyPr lIns="182880" tIns="91440" rtlCol="0" anchor="ctr"/>
           <a:lstStyle/>
           <a:p>
             <a:pPr algn="ctr">
@@ -16756,7 +17276,7 @@
 </file>
 
 <file path=ppt/slides/slide7.xml><?xml version="1.0" encoding="utf-8"?>
-<p:sld xmlns:a="http://schemas.openxmlformats.org/drawingml/2006/main" xmlns:p="http://schemas.openxmlformats.org/presentationml/2006/main" xmlns:r="http://schemas.openxmlformats.org/officeDocument/2006/relationships">
+<p:sld xmlns:a="http://schemas.openxmlformats.org/drawingml/2006/main" xmlns:r="http://schemas.openxmlformats.org/officeDocument/2006/relationships" xmlns:p="http://schemas.openxmlformats.org/presentationml/2006/main">
   <p:cSld>
     <p:bg>
       <p:bgPr>
@@ -16772,7 +17292,14 @@
         <p:cNvGrpSpPr/>
         <p:nvPr/>
       </p:nvGrpSpPr>
-      <p:grpSpPr/>
+      <p:grpSpPr>
+        <a:xfrm>
+          <a:off x="0" y="0"/>
+          <a:ext cx="0" cy="0"/>
+          <a:chOff x="0" y="0"/>
+          <a:chExt cx="0" cy="0"/>
+        </a:xfrm>
+      </p:grpSpPr>
       <p:sp>
         <p:nvSpPr>
           <p:cNvPr id="2" name="Rectangle 1"/>
@@ -16809,7 +17336,7 @@
           </a:fontRef>
         </p:style>
         <p:txBody>
-          <a:bodyPr rtlCol="0" anchor="ctr" wrap="square" lIns="457200" tIns="137160"/>
+          <a:bodyPr wrap="square" lIns="457200" tIns="137160" rtlCol="0" anchor="ctr"/>
           <a:lstStyle/>
           <a:p>
             <a:pPr algn="ctr">
@@ -16917,6 +17444,7 @@
           <a:lstStyle/>
           <a:p>
             <a:pPr algn="ctr"/>
+            <a:endParaRPr/>
           </a:p>
         </p:txBody>
       </p:sp>
@@ -16956,7 +17484,7 @@
           </a:fontRef>
         </p:style>
         <p:txBody>
-          <a:bodyPr rtlCol="0" anchor="ctr" lIns="182880" tIns="91440"/>
+          <a:bodyPr lIns="182880" tIns="91440" rtlCol="0" anchor="ctr"/>
           <a:lstStyle/>
           <a:p>
             <a:pPr algn="ctr">
@@ -17095,6 +17623,7 @@
           <a:lstStyle/>
           <a:p>
             <a:pPr algn="ctr"/>
+            <a:endParaRPr/>
           </a:p>
         </p:txBody>
       </p:sp>
@@ -17134,7 +17663,7 @@
           </a:fontRef>
         </p:style>
         <p:txBody>
-          <a:bodyPr rtlCol="0" anchor="ctr" lIns="182880" tIns="91440"/>
+          <a:bodyPr lIns="182880" tIns="91440" rtlCol="0" anchor="ctr"/>
           <a:lstStyle/>
           <a:p>
             <a:pPr algn="ctr">
@@ -17273,6 +17802,7 @@
           <a:lstStyle/>
           <a:p>
             <a:pPr algn="ctr"/>
+            <a:endParaRPr/>
           </a:p>
         </p:txBody>
       </p:sp>
@@ -17312,7 +17842,7 @@
           </a:fontRef>
         </p:style>
         <p:txBody>
-          <a:bodyPr rtlCol="0" anchor="ctr" lIns="182880" tIns="91440"/>
+          <a:bodyPr lIns="182880" tIns="91440" rtlCol="0" anchor="ctr"/>
           <a:lstStyle/>
           <a:p>
             <a:pPr algn="ctr">
@@ -17451,6 +17981,7 @@
           <a:lstStyle/>
           <a:p>
             <a:pPr algn="ctr"/>
+            <a:endParaRPr/>
           </a:p>
         </p:txBody>
       </p:sp>
@@ -17490,7 +18021,7 @@
           </a:fontRef>
         </p:style>
         <p:txBody>
-          <a:bodyPr rtlCol="0" anchor="ctr" lIns="182880" tIns="91440"/>
+          <a:bodyPr lIns="182880" tIns="91440" rtlCol="0" anchor="ctr"/>
           <a:lstStyle/>
           <a:p>
             <a:pPr algn="ctr">
@@ -17596,7 +18127,7 @@
 </file>
 
 <file path=ppt/slides/slide8.xml><?xml version="1.0" encoding="utf-8"?>
-<p:sld xmlns:a="http://schemas.openxmlformats.org/drawingml/2006/main" xmlns:p="http://schemas.openxmlformats.org/presentationml/2006/main" xmlns:r="http://schemas.openxmlformats.org/officeDocument/2006/relationships">
+<p:sld xmlns:a="http://schemas.openxmlformats.org/drawingml/2006/main" xmlns:r="http://schemas.openxmlformats.org/officeDocument/2006/relationships" xmlns:p="http://schemas.openxmlformats.org/presentationml/2006/main">
   <p:cSld>
     <p:bg>
       <p:bgPr>
@@ -17612,7 +18143,14 @@
         <p:cNvGrpSpPr/>
         <p:nvPr/>
       </p:nvGrpSpPr>
-      <p:grpSpPr/>
+      <p:grpSpPr>
+        <a:xfrm>
+          <a:off x="0" y="0"/>
+          <a:ext cx="0" cy="0"/>
+          <a:chOff x="0" y="0"/>
+          <a:chExt cx="0" cy="0"/>
+        </a:xfrm>
+      </p:grpSpPr>
       <p:sp>
         <p:nvSpPr>
           <p:cNvPr id="2" name="Rectangle 1"/>
@@ -17649,7 +18187,7 @@
           </a:fontRef>
         </p:style>
         <p:txBody>
-          <a:bodyPr rtlCol="0" anchor="ctr" wrap="square" lIns="457200" tIns="137160"/>
+          <a:bodyPr wrap="square" lIns="457200" tIns="137160" rtlCol="0" anchor="ctr"/>
           <a:lstStyle/>
           <a:p>
             <a:pPr algn="ctr">
@@ -17757,6 +18295,7 @@
           <a:lstStyle/>
           <a:p>
             <a:pPr algn="ctr"/>
+            <a:endParaRPr/>
           </a:p>
         </p:txBody>
       </p:sp>
@@ -17796,7 +18335,7 @@
           </a:fontRef>
         </p:style>
         <p:txBody>
-          <a:bodyPr rtlCol="0" anchor="ctr" lIns="182880" tIns="91440"/>
+          <a:bodyPr lIns="182880" tIns="91440" rtlCol="0" anchor="ctr"/>
           <a:lstStyle/>
           <a:p>
             <a:pPr algn="ctr">
@@ -17939,6 +18478,7 @@
           <a:lstStyle/>
           <a:p>
             <a:pPr algn="ctr"/>
+            <a:endParaRPr/>
           </a:p>
         </p:txBody>
       </p:sp>
@@ -17978,7 +18518,7 @@
           </a:fontRef>
         </p:style>
         <p:txBody>
-          <a:bodyPr rtlCol="0" anchor="ctr" lIns="182880" tIns="91440"/>
+          <a:bodyPr lIns="182880" tIns="91440" rtlCol="0" anchor="ctr"/>
           <a:lstStyle/>
           <a:p>
             <a:pPr algn="ctr">
@@ -18072,7 +18612,7 @@
 </file>
 
 <file path=ppt/slides/slide9.xml><?xml version="1.0" encoding="utf-8"?>
-<p:sld xmlns:a="http://schemas.openxmlformats.org/drawingml/2006/main" xmlns:p="http://schemas.openxmlformats.org/presentationml/2006/main" xmlns:r="http://schemas.openxmlformats.org/officeDocument/2006/relationships">
+<p:sld xmlns:a="http://schemas.openxmlformats.org/drawingml/2006/main" xmlns:r="http://schemas.openxmlformats.org/officeDocument/2006/relationships" xmlns:p="http://schemas.openxmlformats.org/presentationml/2006/main">
   <p:cSld>
     <p:bg>
       <p:bgPr>
@@ -18088,7 +18628,14 @@
         <p:cNvGrpSpPr/>
         <p:nvPr/>
       </p:nvGrpSpPr>
-      <p:grpSpPr/>
+      <p:grpSpPr>
+        <a:xfrm>
+          <a:off x="0" y="0"/>
+          <a:ext cx="0" cy="0"/>
+          <a:chOff x="0" y="0"/>
+          <a:chExt cx="0" cy="0"/>
+        </a:xfrm>
+      </p:grpSpPr>
       <p:sp>
         <p:nvSpPr>
           <p:cNvPr id="2" name="Rectangle 1"/>
@@ -18125,7 +18672,7 @@
           </a:fontRef>
         </p:style>
         <p:txBody>
-          <a:bodyPr rtlCol="0" anchor="ctr" wrap="square" lIns="457200" tIns="137160"/>
+          <a:bodyPr wrap="square" lIns="457200" tIns="137160" rtlCol="0" anchor="ctr"/>
           <a:lstStyle/>
           <a:p>
             <a:pPr algn="ctr">

</xml_diff>